<commit_message>
fix(adjustments): rename column to Substitute Remarks / Response and format response states
</commit_message>
<xml_diff>
--- a/Project_Final_Presentation_V2.pptx
+++ b/Project_Final_Presentation_V2.pptx
@@ -24,6 +24,7 @@
     <p:sldId id="272" r:id="rId18"/>
     <p:sldId id="273" r:id="rId19"/>
     <p:sldId id="274" r:id="rId20"/>
+    <p:sldId id="275" r:id="rId21"/>
   </p:sldIdLst>
   <p:sldSz cx="12192000" cy="6858000"/>
   <p:notesSz cx="6858000" cy="9144000"/>
@@ -320,7 +321,7 @@
           <a:p>
             <a:fld id="{5BCAD085-E8A6-8845-BD4E-CB4CCA059FC4}" type="datetimeFigureOut">
               <a:rPr lang="en-US" smtClean="0"/>
-              <a:t>10/1/2026</a:t>
+              <a:t>10/2/2026</a:t>
             </a:fld>
             <a:endParaRPr lang="en-US"/>
           </a:p>
@@ -488,7 +489,7 @@
           <a:p>
             <a:fld id="{5BCAD085-E8A6-8845-BD4E-CB4CCA059FC4}" type="datetimeFigureOut">
               <a:rPr lang="en-US" smtClean="0"/>
-              <a:t>10/1/2026</a:t>
+              <a:t>10/2/2026</a:t>
             </a:fld>
             <a:endParaRPr lang="en-US"/>
           </a:p>
@@ -666,7 +667,7 @@
           <a:p>
             <a:fld id="{5BCAD085-E8A6-8845-BD4E-CB4CCA059FC4}" type="datetimeFigureOut">
               <a:rPr lang="en-US" smtClean="0"/>
-              <a:t>10/1/2026</a:t>
+              <a:t>10/2/2026</a:t>
             </a:fld>
             <a:endParaRPr lang="en-US"/>
           </a:p>
@@ -834,7 +835,7 @@
           <a:p>
             <a:fld id="{5BCAD085-E8A6-8845-BD4E-CB4CCA059FC4}" type="datetimeFigureOut">
               <a:rPr lang="en-US" smtClean="0"/>
-              <a:t>10/1/2026</a:t>
+              <a:t>10/2/2026</a:t>
             </a:fld>
             <a:endParaRPr lang="en-US"/>
           </a:p>
@@ -1079,7 +1080,7 @@
           <a:p>
             <a:fld id="{5BCAD085-E8A6-8845-BD4E-CB4CCA059FC4}" type="datetimeFigureOut">
               <a:rPr lang="en-US" smtClean="0"/>
-              <a:t>10/1/2026</a:t>
+              <a:t>10/2/2026</a:t>
             </a:fld>
             <a:endParaRPr lang="en-US"/>
           </a:p>
@@ -1364,7 +1365,7 @@
           <a:p>
             <a:fld id="{5BCAD085-E8A6-8845-BD4E-CB4CCA059FC4}" type="datetimeFigureOut">
               <a:rPr lang="en-US" smtClean="0"/>
-              <a:t>10/1/2026</a:t>
+              <a:t>10/2/2026</a:t>
             </a:fld>
             <a:endParaRPr lang="en-US"/>
           </a:p>
@@ -1783,7 +1784,7 @@
           <a:p>
             <a:fld id="{5BCAD085-E8A6-8845-BD4E-CB4CCA059FC4}" type="datetimeFigureOut">
               <a:rPr lang="en-US" smtClean="0"/>
-              <a:t>10/1/2026</a:t>
+              <a:t>10/2/2026</a:t>
             </a:fld>
             <a:endParaRPr lang="en-US"/>
           </a:p>
@@ -1900,7 +1901,7 @@
           <a:p>
             <a:fld id="{5BCAD085-E8A6-8845-BD4E-CB4CCA059FC4}" type="datetimeFigureOut">
               <a:rPr lang="en-US" smtClean="0"/>
-              <a:t>10/1/2026</a:t>
+              <a:t>10/2/2026</a:t>
             </a:fld>
             <a:endParaRPr lang="en-US"/>
           </a:p>
@@ -1995,7 +1996,7 @@
           <a:p>
             <a:fld id="{5BCAD085-E8A6-8845-BD4E-CB4CCA059FC4}" type="datetimeFigureOut">
               <a:rPr lang="en-US" smtClean="0"/>
-              <a:t>10/1/2026</a:t>
+              <a:t>10/2/2026</a:t>
             </a:fld>
             <a:endParaRPr lang="en-US"/>
           </a:p>
@@ -2270,7 +2271,7 @@
           <a:p>
             <a:fld id="{5BCAD085-E8A6-8845-BD4E-CB4CCA059FC4}" type="datetimeFigureOut">
               <a:rPr lang="en-US" smtClean="0"/>
-              <a:t>10/1/2026</a:t>
+              <a:t>10/2/2026</a:t>
             </a:fld>
             <a:endParaRPr lang="en-US"/>
           </a:p>
@@ -2522,7 +2523,7 @@
           <a:p>
             <a:fld id="{5BCAD085-E8A6-8845-BD4E-CB4CCA059FC4}" type="datetimeFigureOut">
               <a:rPr lang="en-US" smtClean="0"/>
-              <a:t>10/1/2026</a:t>
+              <a:t>10/2/2026</a:t>
             </a:fld>
             <a:endParaRPr lang="en-US"/>
           </a:p>
@@ -2733,7 +2734,7 @@
           <a:p>
             <a:fld id="{5BCAD085-E8A6-8845-BD4E-CB4CCA059FC4}" type="datetimeFigureOut">
               <a:rPr lang="en-US" smtClean="0"/>
-              <a:t>10/1/2026</a:t>
+              <a:t>10/2/2026</a:t>
             </a:fld>
             <a:endParaRPr lang="en-US"/>
           </a:p>
@@ -3202,61 +3203,6 @@
       </p:sp>
       <p:sp>
         <p:nvSpPr>
-          <p:cNvPr id="4" name="Rounded Rectangle 3"/>
-          <p:cNvSpPr/>
-          <p:nvPr/>
-        </p:nvSpPr>
-        <p:spPr>
-          <a:xfrm>
-            <a:off x="1097280" y="914400"/>
-            <a:ext cx="5943600" cy="457200"/>
-          </a:xfrm>
-          <a:prstGeom prst="roundRect">
-            <a:avLst/>
-          </a:prstGeom>
-          <a:solidFill>
-            <a:srgbClr val="091024"/>
-          </a:solidFill>
-          <a:ln w="15240">
-            <a:solidFill>
-              <a:srgbClr val="D4AF37"/>
-            </a:solidFill>
-          </a:ln>
-        </p:spPr>
-        <p:style>
-          <a:lnRef idx="1">
-            <a:schemeClr val="accent1"/>
-          </a:lnRef>
-          <a:fillRef idx="3">
-            <a:schemeClr val="accent1"/>
-          </a:fillRef>
-          <a:effectRef idx="2">
-            <a:schemeClr val="accent1"/>
-          </a:effectRef>
-          <a:fontRef idx="minor">
-            <a:schemeClr val="lt1"/>
-          </a:fontRef>
-        </p:style>
-        <p:txBody>
-          <a:bodyPr rtlCol="0" anchor="ctr"/>
-          <a:lstStyle/>
-          <a:p>
-            <a:pPr algn="ctr">
-              <a:defRPr sz="1300" b="1">
-                <a:solidFill>
-                  <a:srgbClr val="D4AF37"/>
-                </a:solidFill>
-                <a:latin typeface="Calibri"/>
-              </a:defRPr>
-            </a:pPr>
-            <a:r>
-              <a:t>🏛️ SOFTWARE TECHNOLOGY DOMAIN  |  FINAL PROJECT</a:t>
-            </a:r>
-          </a:p>
-        </p:txBody>
-      </p:sp>
-      <p:sp>
-        <p:nvSpPr>
           <p:cNvPr id="5" name="TextBox 4"/>
           <p:cNvSpPr txBox="1"/>
           <p:nvPr/>
@@ -3264,7 +3210,7 @@
         <p:spPr>
           <a:xfrm>
             <a:off x="1097280" y="1508760"/>
-            <a:ext cx="9966960" cy="1645920"/>
+            <a:ext cx="9966960" cy="1323439"/>
           </a:xfrm>
           <a:prstGeom prst="rect">
             <a:avLst/>
@@ -3286,10 +3232,26 @@
               </a:defRPr>
             </a:pPr>
             <a:r>
+              <a:rPr lang="en-IN" i="1" dirty="0">
+                <a:latin typeface="Algerian" panose="04020705040A02060702" pitchFamily="82" charset="0"/>
+              </a:rPr>
+              <a:t>SIDDHI:</a:t>
+            </a:r>
+            <a:r>
+              <a:rPr i="1" dirty="0">
+                <a:latin typeface="Algerian" panose="04020705040A02060702" pitchFamily="82" charset="0"/>
+              </a:rPr>
               <a:t>Outcome-Based Learning Management &amp;</a:t>
             </a:r>
-            <a:br/>
-            <a:r>
+            <a:br>
+              <a:rPr i="1" dirty="0">
+                <a:latin typeface="Algerian" panose="04020705040A02060702" pitchFamily="82" charset="0"/>
+              </a:rPr>
+            </a:br>
+            <a:r>
+              <a:rPr i="1" dirty="0">
+                <a:latin typeface="Algerian" panose="04020705040A02060702" pitchFamily="82" charset="0"/>
+              </a:rPr>
               <a:t>Accreditation Governance System (OBLMS)</a:t>
             </a:r>
           </a:p>
@@ -3303,8 +3265,14 @@
               </a:defRPr>
             </a:pPr>
             <a:r>
-              <a:t>An Enterprise Platform for Automated CO-PO Attainment, Faculty Workload &amp; Marksheet Governance</a:t>
-            </a:r>
+              <a:rPr lang="en-IN" sz="2400" dirty="0">
+                <a:latin typeface="Castellar" panose="020A0402060406010301" pitchFamily="18" charset="0"/>
+              </a:rPr>
+              <a:t>                DOMAIN- SOFTWARE TECHNOLOGY</a:t>
+            </a:r>
+            <a:endParaRPr sz="2400" dirty="0">
+              <a:latin typeface="Castellar" panose="020A0402060406010301" pitchFamily="18" charset="0"/>
+            </a:endParaRPr>
           </a:p>
         </p:txBody>
       </p:sp>
@@ -3316,8 +3284,8 @@
         </p:nvSpPr>
         <p:spPr>
           <a:xfrm>
-            <a:off x="1097280" y="3383280"/>
-            <a:ext cx="4754880" cy="2377440"/>
+            <a:off x="906024" y="3429000"/>
+            <a:ext cx="5174736" cy="2251219"/>
           </a:xfrm>
           <a:prstGeom prst="roundRect">
             <a:avLst/>
@@ -3350,19 +3318,6 @@
           <a:lstStyle/>
           <a:p>
             <a:pPr algn="ctr">
-              <a:defRPr sz="1500" b="1">
-                <a:solidFill>
-                  <a:srgbClr val="FDE68A"/>
-                </a:solidFill>
-                <a:latin typeface="Calibri"/>
-              </a:defRPr>
-            </a:pPr>
-            <a:r>
-              <a:t>👥 Project Author &amp; Student</a:t>
-            </a:r>
-          </a:p>
-          <a:p>
-            <a:pPr>
               <a:defRPr sz="1300">
                 <a:solidFill>
                   <a:srgbClr val="E2E8F0"/>
@@ -3371,11 +3326,14 @@
               </a:defRPr>
             </a:pPr>
             <a:r>
-              <a:t>• Student Name: V. Krishna Vamsi</a:t>
-            </a:r>
-          </a:p>
-          <a:p>
-            <a:pPr>
+              <a:rPr lang="en-IN" sz="2000" dirty="0">
+                <a:latin typeface="Lucida Handwriting" panose="03010101010101010101" pitchFamily="66" charset="0"/>
+              </a:rPr>
+              <a:t>Malla Loukika-240101120034</a:t>
+            </a:r>
+          </a:p>
+          <a:p>
+            <a:pPr algn="ctr">
               <a:defRPr sz="1300">
                 <a:solidFill>
                   <a:srgbClr val="E2E8F0"/>
@@ -3384,11 +3342,20 @@
               </a:defRPr>
             </a:pPr>
             <a:r>
-              <a:t>• Registration No: CUTM2026CSE042 (STU004)</a:t>
-            </a:r>
-          </a:p>
-          <a:p>
-            <a:pPr>
+              <a:rPr lang="en-IN" sz="2000" dirty="0" err="1">
+                <a:latin typeface="Lucida Handwriting" panose="03010101010101010101" pitchFamily="66" charset="0"/>
+              </a:rPr>
+              <a:t>Dandela</a:t>
+            </a:r>
+            <a:r>
+              <a:rPr lang="en-IN" sz="2000" dirty="0">
+                <a:latin typeface="Lucida Handwriting" panose="03010101010101010101" pitchFamily="66" charset="0"/>
+              </a:rPr>
+              <a:t> Naga Krishna Vamsi-240101120041</a:t>
+            </a:r>
+          </a:p>
+          <a:p>
+            <a:pPr algn="ctr">
               <a:defRPr sz="1300">
                 <a:solidFill>
                   <a:srgbClr val="E2E8F0"/>
@@ -3397,34 +3364,93 @@
               </a:defRPr>
             </a:pPr>
             <a:r>
-              <a:t>• Program: B.Tech Computer Science &amp; Engg.</a:t>
-            </a:r>
-          </a:p>
-          <a:p>
-            <a:pPr>
-              <a:defRPr sz="1300">
-                <a:solidFill>
-                  <a:srgbClr val="E2E8F0"/>
-                </a:solidFill>
-                <a:latin typeface="Calibri"/>
-              </a:defRPr>
-            </a:pPr>
-            <a:r>
-              <a:t>• Academic Year: 2026 – 2027 (Final Year B.Tech)</a:t>
-            </a:r>
-          </a:p>
-        </p:txBody>
-      </p:sp>
-      <p:sp>
-        <p:nvSpPr>
-          <p:cNvPr id="7" name="Rounded Rectangle 6"/>
+              <a:rPr lang="en-IN" sz="2000" dirty="0" err="1">
+                <a:latin typeface="Lucida Handwriting" panose="03010101010101010101" pitchFamily="66" charset="0"/>
+              </a:rPr>
+              <a:t>Taddi</a:t>
+            </a:r>
+            <a:r>
+              <a:rPr lang="en-IN" sz="2000" dirty="0">
+                <a:latin typeface="Lucida Handwriting" panose="03010101010101010101" pitchFamily="66" charset="0"/>
+              </a:rPr>
+              <a:t> Santosh Vardhan-240101120021</a:t>
+            </a:r>
+            <a:endParaRPr sz="2000" dirty="0">
+              <a:latin typeface="Lucida Handwriting" panose="03010101010101010101" pitchFamily="66" charset="0"/>
+            </a:endParaRPr>
+          </a:p>
+        </p:txBody>
+      </p:sp>
+      <p:sp>
+        <p:nvSpPr>
+          <p:cNvPr id="9" name="TextBox 8">
+            <a:extLst>
+              <a:ext uri="{FF2B5EF4-FFF2-40B4-BE49-F238E27FC236}">
+                <a16:creationId xmlns:a16="http://schemas.microsoft.com/office/drawing/2014/main" id="{C6704FF1-8E7F-353B-4FD9-0BC61D5C21FA}"/>
+              </a:ext>
+            </a:extLst>
+          </p:cNvPr>
+          <p:cNvSpPr txBox="1"/>
+          <p:nvPr/>
+        </p:nvSpPr>
+        <p:spPr>
+          <a:xfrm>
+            <a:off x="2317446" y="3516213"/>
+            <a:ext cx="2657226" cy="369332"/>
+          </a:xfrm>
+          <a:prstGeom prst="rect">
+            <a:avLst/>
+          </a:prstGeom>
+          <a:noFill/>
+          <a:ln>
+            <a:solidFill>
+              <a:schemeClr val="tx1"/>
+            </a:solidFill>
+          </a:ln>
+        </p:spPr>
+        <p:txBody>
+          <a:bodyPr wrap="square" rtlCol="0">
+            <a:spAutoFit/>
+          </a:bodyPr>
+          <a:lstStyle/>
+          <a:p>
+            <a:r>
+              <a:rPr lang="en-IN" dirty="0">
+                <a:solidFill>
+                  <a:schemeClr val="bg1"/>
+                </a:solidFill>
+                <a:latin typeface="Algerian" panose="04020705040A02060702" pitchFamily="82" charset="0"/>
+              </a:rPr>
+              <a:t>    </a:t>
+            </a:r>
+            <a:r>
+              <a:rPr lang="en-IN" dirty="0">
+                <a:solidFill>
+                  <a:schemeClr val="bg1"/>
+                </a:solidFill>
+                <a:latin typeface="Lucida Handwriting" panose="03010101010101010101" pitchFamily="66" charset="0"/>
+              </a:rPr>
+              <a:t>TEAM MEMBERS</a:t>
+            </a:r>
+          </a:p>
+        </p:txBody>
+      </p:sp>
+      <p:sp>
+        <p:nvSpPr>
+          <p:cNvPr id="7" name="Rounded Rectangle 5">
+            <a:extLst>
+              <a:ext uri="{FF2B5EF4-FFF2-40B4-BE49-F238E27FC236}">
+                <a16:creationId xmlns:a16="http://schemas.microsoft.com/office/drawing/2014/main" id="{3D45F061-21B7-D230-AFA3-C6ACE2C54222}"/>
+              </a:ext>
+            </a:extLst>
+          </p:cNvPr>
           <p:cNvSpPr/>
           <p:nvPr/>
         </p:nvSpPr>
         <p:spPr>
           <a:xfrm>
-            <a:off x="6126480" y="3383280"/>
-            <a:ext cx="4937760" cy="2377440"/>
+            <a:off x="6088273" y="3386183"/>
+            <a:ext cx="5174737" cy="2251219"/>
           </a:xfrm>
           <a:prstGeom prst="roundRect">
             <a:avLst/>
@@ -3457,19 +3483,6 @@
           <a:lstStyle/>
           <a:p>
             <a:pPr algn="ctr">
-              <a:defRPr sz="1500" b="1">
-                <a:solidFill>
-                  <a:srgbClr val="FDE68A"/>
-                </a:solidFill>
-                <a:latin typeface="Calibri"/>
-              </a:defRPr>
-            </a:pPr>
-            <a:r>
-              <a:t>🏛️ Supervision &amp; Institution</a:t>
-            </a:r>
-          </a:p>
-          <a:p>
-            <a:pPr>
               <a:defRPr sz="1300">
                 <a:solidFill>
                   <a:srgbClr val="E2E8F0"/>
@@ -3478,11 +3491,14 @@
               </a:defRPr>
             </a:pPr>
             <a:r>
-              <a:t>• Project Guide: Project Faculty Guide / Supervisor</a:t>
-            </a:r>
-          </a:p>
-          <a:p>
-            <a:pPr>
+              <a:rPr lang="en-IN" sz="2000" dirty="0">
+                <a:latin typeface="Lucida Handwriting" panose="03010101010101010101" pitchFamily="66" charset="0"/>
+              </a:rPr>
+              <a:t>Guided By-</a:t>
+            </a:r>
+          </a:p>
+          <a:p>
+            <a:pPr algn="ctr">
               <a:defRPr sz="1300">
                 <a:solidFill>
                   <a:srgbClr val="E2E8F0"/>
@@ -3491,69 +3507,33 @@
               </a:defRPr>
             </a:pPr>
             <a:r>
-              <a:t>• Department: Dept. of Computer Science &amp; Engineering</a:t>
-            </a:r>
-          </a:p>
-          <a:p>
-            <a:pPr>
-              <a:defRPr sz="1300">
-                <a:solidFill>
-                  <a:srgbClr val="E2E8F0"/>
-                </a:solidFill>
-                <a:latin typeface="Calibri"/>
-              </a:defRPr>
-            </a:pPr>
-            <a:r>
-              <a:t>• University: Centurion University of Technology &amp; Management</a:t>
-            </a:r>
-          </a:p>
-          <a:p>
-            <a:pPr>
-              <a:defRPr sz="1300">
-                <a:solidFill>
-                  <a:srgbClr val="E2E8F0"/>
-                </a:solidFill>
-                <a:latin typeface="Calibri"/>
-              </a:defRPr>
-            </a:pPr>
-            <a:r>
-              <a:t>• Accreditation: NBA Tier-1 &amp; NAAC 2.6 Framework</a:t>
-            </a:r>
-          </a:p>
-        </p:txBody>
-      </p:sp>
-      <p:sp>
-        <p:nvSpPr>
-          <p:cNvPr id="8" name="TextBox 7"/>
-          <p:cNvSpPr txBox="1"/>
-          <p:nvPr/>
-        </p:nvSpPr>
-        <p:spPr>
-          <a:xfrm>
-            <a:off x="548640" y="6473952"/>
-            <a:ext cx="11094415" cy="320040"/>
-          </a:xfrm>
-          <a:prstGeom prst="rect">
-            <a:avLst/>
-          </a:prstGeom>
-          <a:noFill/>
-        </p:spPr>
-        <p:txBody>
-          <a:bodyPr wrap="none" tIns="0" bIns="0">
-            <a:spAutoFit/>
-          </a:bodyPr>
-          <a:lstStyle/>
-          <a:p>
-            <a:pPr>
-              <a:defRPr sz="1050">
-                <a:solidFill>
-                  <a:srgbClr val="94A3B8"/>
-                </a:solidFill>
-                <a:latin typeface="Calibri"/>
-              </a:defRPr>
-            </a:pPr>
-            <a:r>
-              <a:t>OBLMS — Outcome-Based Learning Management System  |  Software Technology Project  |  Slide 1 of 20</a:t>
+              <a:rPr lang="en-IN" sz="2000" dirty="0">
+                <a:latin typeface="Lucida Handwriting" panose="03010101010101010101" pitchFamily="66" charset="0"/>
+              </a:rPr>
+              <a:t>Prof. Manoj </a:t>
+            </a:r>
+            <a:r>
+              <a:rPr lang="en-IN" sz="2000" dirty="0" err="1">
+                <a:latin typeface="Lucida Handwriting" panose="03010101010101010101" pitchFamily="66" charset="0"/>
+              </a:rPr>
+              <a:t>Padhy</a:t>
+            </a:r>
+            <a:br>
+              <a:rPr lang="en-IN" sz="2000" dirty="0">
+                <a:latin typeface="Lucida Handwriting" panose="03010101010101010101" pitchFamily="66" charset="0"/>
+              </a:rPr>
+            </a:br>
+            <a:r>
+              <a:rPr lang="en-IN" sz="2000" dirty="0" err="1">
+                <a:latin typeface="Lucida Handwriting" panose="03010101010101010101" pitchFamily="66" charset="0"/>
+              </a:rPr>
+              <a:t>Prof.Biswaranjan</a:t>
+            </a:r>
+            <a:r>
+              <a:rPr lang="en-IN" sz="2000" dirty="0">
+                <a:latin typeface="Lucida Handwriting" panose="03010101010101010101" pitchFamily="66" charset="0"/>
+              </a:rPr>
+              <a:t> Routray</a:t>
             </a:r>
           </a:p>
         </p:txBody>
@@ -3679,6 +3659,7 @@
               </a:defRPr>
             </a:pPr>
             <a:r>
+              <a:rPr dirty="0"/>
               <a:t>10. Major System Modules</a:t>
             </a:r>
           </a:p>
@@ -3691,9 +3672,7 @@
                 <a:latin typeface="Calibri"/>
               </a:defRPr>
             </a:pPr>
-            <a:r>
-              <a:t>Core Functional Units Across User Portals</a:t>
-            </a:r>
+            <a:endParaRPr dirty="0"/>
           </a:p>
         </p:txBody>
       </p:sp>
@@ -3965,42 +3944,6 @@
             </a:pPr>
             <a:r>
               <a:t>On-demand generator for NBA SAR Criterion 3 and NAAC 2.6 dossiers with search filters, pagination, and multi-format download (CSV/JSON/PDF).</a:t>
-            </a:r>
-          </a:p>
-        </p:txBody>
-      </p:sp>
-      <p:sp>
-        <p:nvSpPr>
-          <p:cNvPr id="8" name="TextBox 7"/>
-          <p:cNvSpPr txBox="1"/>
-          <p:nvPr/>
-        </p:nvSpPr>
-        <p:spPr>
-          <a:xfrm>
-            <a:off x="548640" y="6473952"/>
-            <a:ext cx="11094415" cy="320040"/>
-          </a:xfrm>
-          <a:prstGeom prst="rect">
-            <a:avLst/>
-          </a:prstGeom>
-          <a:noFill/>
-        </p:spPr>
-        <p:txBody>
-          <a:bodyPr wrap="none" tIns="0" bIns="0">
-            <a:spAutoFit/>
-          </a:bodyPr>
-          <a:lstStyle/>
-          <a:p>
-            <a:pPr>
-              <a:defRPr sz="1050">
-                <a:solidFill>
-                  <a:srgbClr val="94A3B8"/>
-                </a:solidFill>
-                <a:latin typeface="Calibri"/>
-              </a:defRPr>
-            </a:pPr>
-            <a:r>
-              <a:t>OBLMS — Outcome-Based Learning Management System  |  Software Technology Project  |  Slide 10 of 20</a:t>
             </a:r>
           </a:p>
         </p:txBody>
@@ -4072,10 +4015,6 @@
           <a:lstStyle/>
           <a:p>
             <a:pPr algn="ctr"/>
-            <a:r>
-              <a:rPr lang="en-IN" dirty="0"/>
-              <a:t>UML AND USE CASE DIAGRAM</a:t>
-            </a:r>
             <a:endParaRPr dirty="0"/>
           </a:p>
         </p:txBody>
@@ -4132,6 +4071,268 @@
             <a:r>
               <a:rPr dirty="0"/>
               <a:t>11. UML &amp; Process Workflow Design</a:t>
+            </a:r>
+          </a:p>
+        </p:txBody>
+      </p:sp>
+      <p:sp>
+        <p:nvSpPr>
+          <p:cNvPr id="7" name="Rounded Rectangle 3">
+            <a:extLst>
+              <a:ext uri="{FF2B5EF4-FFF2-40B4-BE49-F238E27FC236}">
+                <a16:creationId xmlns:a16="http://schemas.microsoft.com/office/drawing/2014/main" id="{4D2824B8-BF1D-1DB2-B315-9831F5BE37ED}"/>
+              </a:ext>
+            </a:extLst>
+          </p:cNvPr>
+          <p:cNvSpPr/>
+          <p:nvPr/>
+        </p:nvSpPr>
+        <p:spPr>
+          <a:xfrm>
+            <a:off x="500426" y="1668780"/>
+            <a:ext cx="5394960" cy="4754880"/>
+          </a:xfrm>
+          <a:prstGeom prst="roundRect">
+            <a:avLst/>
+          </a:prstGeom>
+          <a:solidFill>
+            <a:srgbClr val="101B38"/>
+          </a:solidFill>
+          <a:ln w="15240">
+            <a:solidFill>
+              <a:srgbClr val="263862"/>
+            </a:solidFill>
+          </a:ln>
+        </p:spPr>
+        <p:style>
+          <a:lnRef idx="1">
+            <a:schemeClr val="accent1"/>
+          </a:lnRef>
+          <a:fillRef idx="3">
+            <a:schemeClr val="accent1"/>
+          </a:fillRef>
+          <a:effectRef idx="2">
+            <a:schemeClr val="accent1"/>
+          </a:effectRef>
+          <a:fontRef idx="minor">
+            <a:schemeClr val="lt1"/>
+          </a:fontRef>
+        </p:style>
+        <p:txBody>
+          <a:bodyPr wrap="square" lIns="182880" tIns="137160" rtlCol="0" anchor="ctr"/>
+          <a:lstStyle/>
+          <a:p>
+            <a:pPr algn="ctr">
+              <a:defRPr sz="1400" b="1">
+                <a:solidFill>
+                  <a:srgbClr val="D4AF37"/>
+                </a:solidFill>
+                <a:latin typeface="Calibri"/>
+              </a:defRPr>
+            </a:pPr>
+            <a:r>
+              <a:rPr lang="en-IN" dirty="0"/>
+              <a:t>LOGIN PAGE</a:t>
+            </a:r>
+            <a:endParaRPr dirty="0"/>
+          </a:p>
+        </p:txBody>
+      </p:sp>
+      <p:pic>
+        <p:nvPicPr>
+          <p:cNvPr id="9" name="Picture 8">
+            <a:extLst>
+              <a:ext uri="{FF2B5EF4-FFF2-40B4-BE49-F238E27FC236}">
+                <a16:creationId xmlns:a16="http://schemas.microsoft.com/office/drawing/2014/main" id="{CE15FE29-94B9-B405-3CA8-07A3B886B2E6}"/>
+              </a:ext>
+            </a:extLst>
+          </p:cNvPr>
+          <p:cNvPicPr>
+            <a:picLocks noChangeAspect="1"/>
+          </p:cNvPicPr>
+          <p:nvPr/>
+        </p:nvPicPr>
+        <p:blipFill>
+          <a:blip r:embed="rId2"/>
+          <a:stretch>
+            <a:fillRect/>
+          </a:stretch>
+        </p:blipFill>
+        <p:spPr>
+          <a:xfrm>
+            <a:off x="870731" y="2088859"/>
+            <a:ext cx="4750777" cy="4077049"/>
+          </a:xfrm>
+          <a:prstGeom prst="rect">
+            <a:avLst/>
+          </a:prstGeom>
+        </p:spPr>
+      </p:pic>
+      <p:sp>
+        <p:nvSpPr>
+          <p:cNvPr id="11" name="Rounded Rectangle 3">
+            <a:extLst>
+              <a:ext uri="{FF2B5EF4-FFF2-40B4-BE49-F238E27FC236}">
+                <a16:creationId xmlns:a16="http://schemas.microsoft.com/office/drawing/2014/main" id="{C7071552-5C13-DF56-8B70-18A85346DB98}"/>
+              </a:ext>
+            </a:extLst>
+          </p:cNvPr>
+          <p:cNvSpPr/>
+          <p:nvPr/>
+        </p:nvSpPr>
+        <p:spPr>
+          <a:xfrm>
+            <a:off x="6169264" y="1668780"/>
+            <a:ext cx="5394960" cy="4754880"/>
+          </a:xfrm>
+          <a:prstGeom prst="roundRect">
+            <a:avLst/>
+          </a:prstGeom>
+          <a:solidFill>
+            <a:srgbClr val="101B38"/>
+          </a:solidFill>
+          <a:ln w="15240">
+            <a:solidFill>
+              <a:srgbClr val="263862"/>
+            </a:solidFill>
+          </a:ln>
+        </p:spPr>
+        <p:style>
+          <a:lnRef idx="1">
+            <a:schemeClr val="accent1"/>
+          </a:lnRef>
+          <a:fillRef idx="3">
+            <a:schemeClr val="accent1"/>
+          </a:fillRef>
+          <a:effectRef idx="2">
+            <a:schemeClr val="accent1"/>
+          </a:effectRef>
+          <a:fontRef idx="minor">
+            <a:schemeClr val="lt1"/>
+          </a:fontRef>
+        </p:style>
+        <p:txBody>
+          <a:bodyPr wrap="square" lIns="182880" tIns="137160" rtlCol="0" anchor="ctr"/>
+          <a:lstStyle/>
+          <a:p>
+            <a:pPr algn="ctr">
+              <a:defRPr sz="1400" b="1">
+                <a:solidFill>
+                  <a:srgbClr val="D4AF37"/>
+                </a:solidFill>
+                <a:latin typeface="Calibri"/>
+              </a:defRPr>
+            </a:pPr>
+            <a:endParaRPr dirty="0"/>
+          </a:p>
+        </p:txBody>
+      </p:sp>
+      <p:pic>
+        <p:nvPicPr>
+          <p:cNvPr id="13" name="Picture 12">
+            <a:extLst>
+              <a:ext uri="{FF2B5EF4-FFF2-40B4-BE49-F238E27FC236}">
+                <a16:creationId xmlns:a16="http://schemas.microsoft.com/office/drawing/2014/main" id="{C70D1772-4BC6-FABB-F806-9DC54558B477}"/>
+              </a:ext>
+            </a:extLst>
+          </p:cNvPr>
+          <p:cNvPicPr>
+            <a:picLocks noChangeAspect="1"/>
+          </p:cNvPicPr>
+          <p:nvPr/>
+        </p:nvPicPr>
+        <p:blipFill>
+          <a:blip r:embed="rId3"/>
+          <a:stretch>
+            <a:fillRect/>
+          </a:stretch>
+        </p:blipFill>
+        <p:spPr>
+          <a:xfrm>
+            <a:off x="6585055" y="1963024"/>
+            <a:ext cx="4605859" cy="4202884"/>
+          </a:xfrm>
+          <a:prstGeom prst="rect">
+            <a:avLst/>
+          </a:prstGeom>
+        </p:spPr>
+      </p:pic>
+      <p:sp>
+        <p:nvSpPr>
+          <p:cNvPr id="14" name="TextBox 13">
+            <a:extLst>
+              <a:ext uri="{FF2B5EF4-FFF2-40B4-BE49-F238E27FC236}">
+                <a16:creationId xmlns:a16="http://schemas.microsoft.com/office/drawing/2014/main" id="{6CABC7AF-07C9-48B9-9851-E950B3F5A01A}"/>
+              </a:ext>
+            </a:extLst>
+          </p:cNvPr>
+          <p:cNvSpPr txBox="1"/>
+          <p:nvPr/>
+        </p:nvSpPr>
+        <p:spPr>
+          <a:xfrm>
+            <a:off x="2592197" y="1279913"/>
+            <a:ext cx="2776756" cy="400110"/>
+          </a:xfrm>
+          <a:prstGeom prst="rect">
+            <a:avLst/>
+          </a:prstGeom>
+          <a:noFill/>
+        </p:spPr>
+        <p:txBody>
+          <a:bodyPr wrap="square" rtlCol="0">
+            <a:spAutoFit/>
+          </a:bodyPr>
+          <a:lstStyle/>
+          <a:p>
+            <a:r>
+              <a:rPr lang="en-IN" sz="2000" dirty="0">
+                <a:solidFill>
+                  <a:schemeClr val="bg1"/>
+                </a:solidFill>
+                <a:latin typeface="+mj-lt"/>
+              </a:rPr>
+              <a:t>USE-CASE</a:t>
+            </a:r>
+          </a:p>
+        </p:txBody>
+      </p:sp>
+      <p:sp>
+        <p:nvSpPr>
+          <p:cNvPr id="18" name="TextBox 17">
+            <a:extLst>
+              <a:ext uri="{FF2B5EF4-FFF2-40B4-BE49-F238E27FC236}">
+                <a16:creationId xmlns:a16="http://schemas.microsoft.com/office/drawing/2014/main" id="{5487AE7C-9DB9-BF74-CA76-994C7E8FF1DB}"/>
+              </a:ext>
+            </a:extLst>
+          </p:cNvPr>
+          <p:cNvSpPr txBox="1"/>
+          <p:nvPr/>
+        </p:nvSpPr>
+        <p:spPr>
+          <a:xfrm>
+            <a:off x="7961150" y="1251555"/>
+            <a:ext cx="2776756" cy="400110"/>
+          </a:xfrm>
+          <a:prstGeom prst="rect">
+            <a:avLst/>
+          </a:prstGeom>
+          <a:noFill/>
+        </p:spPr>
+        <p:txBody>
+          <a:bodyPr wrap="square" rtlCol="0">
+            <a:spAutoFit/>
+          </a:bodyPr>
+          <a:lstStyle/>
+          <a:p>
+            <a:r>
+              <a:rPr lang="en-IN" sz="2000" dirty="0">
+                <a:solidFill>
+                  <a:schemeClr val="bg1"/>
+                </a:solidFill>
+                <a:latin typeface="+mj-lt"/>
+              </a:rPr>
+              <a:t>UML-CLASS</a:t>
             </a:r>
           </a:p>
         </p:txBody>
@@ -4203,10 +4404,6 @@
           <a:lstStyle/>
           <a:p>
             <a:pPr algn="ctr"/>
-            <a:r>
-              <a:rPr lang="en-IN" dirty="0"/>
-              <a:t>ER DIAGRAM</a:t>
-            </a:r>
             <a:endParaRPr dirty="0"/>
           </a:p>
         </p:txBody>
@@ -4261,9 +4458,10 @@
               </a:defRPr>
             </a:pPr>
             <a:r>
-              <a:rPr dirty="0"/>
-              <a:t>12. Database Design &amp; Schema</a:t>
-            </a:r>
+              <a:rPr lang="en-IN" dirty="0"/>
+              <a:t>ENTITY RELATIONSHIP(ER DIAGRAM)</a:t>
+            </a:r>
+            <a:endParaRPr dirty="0"/>
           </a:p>
           <a:p>
             <a:pPr>
@@ -4278,6 +4476,95 @@
           </a:p>
         </p:txBody>
       </p:sp>
+      <p:sp>
+        <p:nvSpPr>
+          <p:cNvPr id="5" name="Rounded Rectangle 6">
+            <a:extLst>
+              <a:ext uri="{FF2B5EF4-FFF2-40B4-BE49-F238E27FC236}">
+                <a16:creationId xmlns:a16="http://schemas.microsoft.com/office/drawing/2014/main" id="{FD68A839-7C99-EF14-341A-100EAC4A132A}"/>
+              </a:ext>
+            </a:extLst>
+          </p:cNvPr>
+          <p:cNvSpPr/>
+          <p:nvPr/>
+        </p:nvSpPr>
+        <p:spPr>
+          <a:xfrm>
+            <a:off x="548640" y="1600199"/>
+            <a:ext cx="11094415" cy="5110993"/>
+          </a:xfrm>
+          <a:prstGeom prst="roundRect">
+            <a:avLst/>
+          </a:prstGeom>
+          <a:solidFill>
+            <a:srgbClr val="101B38"/>
+          </a:solidFill>
+          <a:ln w="15240">
+            <a:solidFill>
+              <a:srgbClr val="263862"/>
+            </a:solidFill>
+          </a:ln>
+        </p:spPr>
+        <p:style>
+          <a:lnRef idx="1">
+            <a:schemeClr val="accent1"/>
+          </a:lnRef>
+          <a:fillRef idx="3">
+            <a:schemeClr val="accent1"/>
+          </a:fillRef>
+          <a:effectRef idx="2">
+            <a:schemeClr val="accent1"/>
+          </a:effectRef>
+          <a:fontRef idx="minor">
+            <a:schemeClr val="lt1"/>
+          </a:fontRef>
+        </p:style>
+        <p:txBody>
+          <a:bodyPr wrap="square" lIns="182880" tIns="137160" rtlCol="0" anchor="ctr"/>
+          <a:lstStyle/>
+          <a:p>
+            <a:pPr algn="ctr">
+              <a:defRPr sz="1400" b="1">
+                <a:solidFill>
+                  <a:srgbClr val="38BDF8"/>
+                </a:solidFill>
+                <a:latin typeface="Calibri"/>
+              </a:defRPr>
+            </a:pPr>
+            <a:endParaRPr dirty="0"/>
+          </a:p>
+        </p:txBody>
+      </p:sp>
+      <p:pic>
+        <p:nvPicPr>
+          <p:cNvPr id="7" name="Picture 6">
+            <a:extLst>
+              <a:ext uri="{FF2B5EF4-FFF2-40B4-BE49-F238E27FC236}">
+                <a16:creationId xmlns:a16="http://schemas.microsoft.com/office/drawing/2014/main" id="{3D9433C6-6EDD-82E7-CD24-44FB14FF7F14}"/>
+              </a:ext>
+            </a:extLst>
+          </p:cNvPr>
+          <p:cNvPicPr>
+            <a:picLocks noChangeAspect="1"/>
+          </p:cNvPicPr>
+          <p:nvPr/>
+        </p:nvPicPr>
+        <p:blipFill>
+          <a:blip r:embed="rId2"/>
+          <a:stretch>
+            <a:fillRect/>
+          </a:stretch>
+        </p:blipFill>
+        <p:spPr>
+          <a:xfrm>
+            <a:off x="2004970" y="1676748"/>
+            <a:ext cx="8145710" cy="4957893"/>
+          </a:xfrm>
+          <a:prstGeom prst="rect">
+            <a:avLst/>
+          </a:prstGeom>
+        </p:spPr>
+      </p:pic>
     </p:spTree>
   </p:cSld>
   <p:clrMapOvr>
@@ -4400,8 +4687,13 @@
             </a:pPr>
             <a:r>
               <a:rPr dirty="0"/>
-              <a:t>13. User Interface — Governance &amp; Faculty Deck</a:t>
-            </a:r>
+              <a:t>13. User Interface — </a:t>
+            </a:r>
+            <a:r>
+              <a:rPr lang="en-IN" dirty="0"/>
+              <a:t>LOGIN AND STUDENT</a:t>
+            </a:r>
+            <a:endParaRPr dirty="0"/>
           </a:p>
           <a:p>
             <a:pPr>
@@ -4481,7 +4773,7 @@
         </p:nvSpPr>
         <p:spPr>
           <a:xfrm>
-            <a:off x="6217920" y="1417320"/>
+            <a:off x="6370167" y="1417320"/>
             <a:ext cx="5394960" cy="4754880"/>
           </a:xfrm>
           <a:prstGeom prst="roundRect">
@@ -4522,14 +4814,70 @@
                 <a:latin typeface="Calibri"/>
               </a:defRPr>
             </a:pPr>
-            <a:r>
-              <a:rPr lang="en-IN" dirty="0"/>
-              <a:t>STUDENT MAIN DASHBOARD</a:t>
-            </a:r>
             <a:endParaRPr dirty="0"/>
           </a:p>
         </p:txBody>
       </p:sp>
+      <p:pic>
+        <p:nvPicPr>
+          <p:cNvPr id="6" name="Picture 5">
+            <a:extLst>
+              <a:ext uri="{FF2B5EF4-FFF2-40B4-BE49-F238E27FC236}">
+                <a16:creationId xmlns:a16="http://schemas.microsoft.com/office/drawing/2014/main" id="{4FCA3531-E05C-88CC-FB52-15A469F0A6D3}"/>
+              </a:ext>
+            </a:extLst>
+          </p:cNvPr>
+          <p:cNvPicPr>
+            <a:picLocks noChangeAspect="1"/>
+          </p:cNvPicPr>
+          <p:nvPr/>
+        </p:nvPicPr>
+        <p:blipFill>
+          <a:blip r:embed="rId2"/>
+          <a:stretch>
+            <a:fillRect/>
+          </a:stretch>
+        </p:blipFill>
+        <p:spPr>
+          <a:xfrm>
+            <a:off x="1041439" y="1661021"/>
+            <a:ext cx="4461739" cy="4295963"/>
+          </a:xfrm>
+          <a:prstGeom prst="rect">
+            <a:avLst/>
+          </a:prstGeom>
+        </p:spPr>
+      </p:pic>
+      <p:pic>
+        <p:nvPicPr>
+          <p:cNvPr id="9" name="Picture 8">
+            <a:extLst>
+              <a:ext uri="{FF2B5EF4-FFF2-40B4-BE49-F238E27FC236}">
+                <a16:creationId xmlns:a16="http://schemas.microsoft.com/office/drawing/2014/main" id="{8B1CADFF-8AF8-D3B8-5C69-134EE925FF1A}"/>
+              </a:ext>
+            </a:extLst>
+          </p:cNvPr>
+          <p:cNvPicPr>
+            <a:picLocks noChangeAspect="1"/>
+          </p:cNvPicPr>
+          <p:nvPr/>
+        </p:nvPicPr>
+        <p:blipFill>
+          <a:blip r:embed="rId3"/>
+          <a:stretch>
+            <a:fillRect/>
+          </a:stretch>
+        </p:blipFill>
+        <p:spPr>
+          <a:xfrm>
+            <a:off x="6492240" y="1837189"/>
+            <a:ext cx="4961754" cy="3833769"/>
+          </a:xfrm>
+          <a:prstGeom prst="rect">
+            <a:avLst/>
+          </a:prstGeom>
+        </p:spPr>
+      </p:pic>
     </p:spTree>
   </p:cSld>
   <p:clrMapOvr>
@@ -4652,8 +5000,13 @@
             </a:pPr>
             <a:r>
               <a:rPr dirty="0"/>
-              <a:t>14. User Interface — Results &amp; Reports</a:t>
-            </a:r>
+              <a:t>14. User Interface — </a:t>
+            </a:r>
+            <a:r>
+              <a:rPr lang="en-IN" dirty="0"/>
+              <a:t>FACULTY AND ADMIN</a:t>
+            </a:r>
+            <a:endParaRPr dirty="0"/>
           </a:p>
           <a:p>
             <a:pPr>
@@ -4717,10 +5070,6 @@
                 <a:latin typeface="Calibri"/>
               </a:defRPr>
             </a:pPr>
-            <a:r>
-              <a:rPr lang="en-IN" dirty="0"/>
-              <a:t>FACULTY DASHBOARD</a:t>
-            </a:r>
             <a:endParaRPr dirty="0"/>
           </a:p>
         </p:txBody>
@@ -4774,14 +5123,70 @@
                 <a:latin typeface="Calibri"/>
               </a:defRPr>
             </a:pPr>
-            <a:r>
-              <a:rPr lang="en-IN" dirty="0"/>
-              <a:t>ADMIN DASHBOARD</a:t>
-            </a:r>
             <a:endParaRPr dirty="0"/>
           </a:p>
         </p:txBody>
       </p:sp>
+      <p:pic>
+        <p:nvPicPr>
+          <p:cNvPr id="6" name="Picture 5">
+            <a:extLst>
+              <a:ext uri="{FF2B5EF4-FFF2-40B4-BE49-F238E27FC236}">
+                <a16:creationId xmlns:a16="http://schemas.microsoft.com/office/drawing/2014/main" id="{DEDA83F5-1A73-A050-D619-377A1E6CC3FC}"/>
+              </a:ext>
+            </a:extLst>
+          </p:cNvPr>
+          <p:cNvPicPr>
+            <a:picLocks noChangeAspect="1"/>
+          </p:cNvPicPr>
+          <p:nvPr/>
+        </p:nvPicPr>
+        <p:blipFill>
+          <a:blip r:embed="rId2"/>
+          <a:stretch>
+            <a:fillRect/>
+          </a:stretch>
+        </p:blipFill>
+        <p:spPr>
+          <a:xfrm>
+            <a:off x="876039" y="1961765"/>
+            <a:ext cx="4740162" cy="3665989"/>
+          </a:xfrm>
+          <a:prstGeom prst="rect">
+            <a:avLst/>
+          </a:prstGeom>
+        </p:spPr>
+      </p:pic>
+      <p:pic>
+        <p:nvPicPr>
+          <p:cNvPr id="9" name="Picture 8">
+            <a:extLst>
+              <a:ext uri="{FF2B5EF4-FFF2-40B4-BE49-F238E27FC236}">
+                <a16:creationId xmlns:a16="http://schemas.microsoft.com/office/drawing/2014/main" id="{3F786230-FCF6-79BF-CE32-198DF6962883}"/>
+              </a:ext>
+            </a:extLst>
+          </p:cNvPr>
+          <p:cNvPicPr>
+            <a:picLocks noChangeAspect="1"/>
+          </p:cNvPicPr>
+          <p:nvPr/>
+        </p:nvPicPr>
+        <p:blipFill>
+          <a:blip r:embed="rId3"/>
+          <a:stretch>
+            <a:fillRect/>
+          </a:stretch>
+        </p:blipFill>
+        <p:spPr>
+          <a:xfrm>
+            <a:off x="6492240" y="2025101"/>
+            <a:ext cx="4800773" cy="3671023"/>
+          </a:xfrm>
+          <a:prstGeom prst="rect">
+            <a:avLst/>
+          </a:prstGeom>
+        </p:spPr>
+      </p:pic>
     </p:spTree>
   </p:cSld>
   <p:clrMapOvr>
@@ -4903,6 +5308,7 @@
               </a:defRPr>
             </a:pPr>
             <a:r>
+              <a:rPr dirty="0"/>
               <a:t>15. Testing Strategy &amp; Verification Results</a:t>
             </a:r>
           </a:p>
@@ -4915,9 +5321,7 @@
                 <a:latin typeface="Calibri"/>
               </a:defRPr>
             </a:pPr>
-            <a:r>
-              <a:t>Empirical Test Matrix and Quality Assurance Evidence</a:t>
-            </a:r>
+            <a:endParaRPr dirty="0"/>
           </a:p>
         </p:txBody>
       </p:sp>
@@ -5984,20 +6388,8 @@
               </a:defRPr>
             </a:pPr>
             <a:r>
+              <a:rPr dirty="0"/>
               <a:t>17. Team Contributions &amp; Roles</a:t>
-            </a:r>
-          </a:p>
-          <a:p>
-            <a:pPr>
-              <a:defRPr sz="1300">
-                <a:solidFill>
-                  <a:srgbClr val="FDE68A"/>
-                </a:solidFill>
-                <a:latin typeface="Calibri"/>
-              </a:defRPr>
-            </a:pPr>
-            <a:r>
-              <a:t>Individual Ownership and Architectural Contributions</a:t>
             </a:r>
           </a:p>
         </p:txBody>
@@ -6011,7 +6403,7 @@
         <p:spPr>
           <a:xfrm>
             <a:off x="548640" y="1417320"/>
-            <a:ext cx="5394960" cy="2240280"/>
+            <a:ext cx="5327848" cy="2903010"/>
           </a:xfrm>
           <a:prstGeom prst="roundRect">
             <a:avLst/>
@@ -6052,47 +6444,121 @@
               </a:defRPr>
             </a:pPr>
             <a:r>
-              <a:t>👨‍💻 V. Krishna Vamsi  |  Project Lead &amp; Full-Stack Architect</a:t>
-            </a:r>
-          </a:p>
-          <a:p>
-            <a:pPr>
-              <a:defRPr sz="1300">
-                <a:solidFill>
-                  <a:srgbClr val="E2E8F0"/>
-                </a:solidFill>
-                <a:latin typeface="Calibri"/>
-              </a:defRPr>
-            </a:pPr>
-            <a:r>
-              <a:t>• Architected Angular 18 Single Page Application and reactive SyncService.</a:t>
-            </a:r>
-          </a:p>
-          <a:p>
-            <a:pPr>
-              <a:defRPr sz="1300">
-                <a:solidFill>
-                  <a:srgbClr val="E2E8F0"/>
-                </a:solidFill>
-                <a:latin typeface="Calibri"/>
-              </a:defRPr>
-            </a:pPr>
-            <a:r>
-              <a:t>• Implemented OBE Mathematical Engine (SGPA/CGPA, CO-PO Matrices).</a:t>
-            </a:r>
-          </a:p>
-          <a:p>
-            <a:pPr>
-              <a:defRPr sz="1300">
-                <a:solidFill>
-                  <a:srgbClr val="E2E8F0"/>
-                </a:solidFill>
-                <a:latin typeface="Calibri"/>
-              </a:defRPr>
-            </a:pPr>
-            <a:r>
-              <a:t>• Designed Master-Detail Student Results Deck &amp; Faculty Workload Deck.</a:t>
-            </a:r>
+              <a:rPr dirty="0"/>
+              <a:t>👨‍💻 </a:t>
+            </a:r>
+            <a:r>
+              <a:rPr lang="en-IN" dirty="0"/>
+              <a:t>D</a:t>
+            </a:r>
+            <a:r>
+              <a:rPr dirty="0"/>
+              <a:t>. Krishna Vamsi  </a:t>
+            </a:r>
+            <a:endParaRPr lang="en-IN" dirty="0"/>
+          </a:p>
+          <a:p>
+            <a:r>
+              <a:rPr lang="en-IN" sz="1200" b="1" dirty="0"/>
+              <a:t>Admin &amp; Governance Architecture Lead</a:t>
+            </a:r>
+          </a:p>
+          <a:p>
+            <a:pPr lvl="0"/>
+            <a:r>
+              <a:rPr lang="en-IN" sz="1200" b="1" dirty="0"/>
+              <a:t>Primary Module:</a:t>
+            </a:r>
+            <a:r>
+              <a:rPr lang="en-IN" sz="1200" dirty="0"/>
+              <a:t> </a:t>
+            </a:r>
+            <a:r>
+              <a:rPr lang="en-IN" sz="1200" b="1" dirty="0"/>
+              <a:t>Admin Console &amp; Institution Governance</a:t>
+            </a:r>
+            <a:r>
+              <a:rPr lang="en-IN" sz="1200" dirty="0"/>
+              <a:t> </a:t>
+            </a:r>
+          </a:p>
+          <a:p>
+            <a:pPr lvl="1"/>
+            <a:r>
+              <a:rPr lang="en-IN" sz="1200" dirty="0"/>
+              <a:t>Built Admin Dashboard for department-wise student/faculty allocation.</a:t>
+            </a:r>
+          </a:p>
+          <a:p>
+            <a:pPr lvl="0"/>
+            <a:r>
+              <a:rPr lang="en-IN" sz="1200" b="1" dirty="0"/>
+              <a:t>Engineering &amp; Architecture Ownership:</a:t>
+            </a:r>
+            <a:r>
+              <a:rPr lang="en-IN" sz="1200" dirty="0"/>
+              <a:t> </a:t>
+            </a:r>
+          </a:p>
+          <a:p>
+            <a:pPr lvl="1"/>
+            <a:r>
+              <a:rPr lang="en-IN" sz="1200" b="1" dirty="0"/>
+              <a:t>Database Schema Design:</a:t>
+            </a:r>
+            <a:r>
+              <a:rPr lang="en-IN" sz="1200" dirty="0"/>
+              <a:t> Relational database schema (users, courses, departments, </a:t>
+            </a:r>
+            <a:r>
+              <a:rPr lang="en-IN" sz="1200" dirty="0" err="1"/>
+              <a:t>enrollments</a:t>
+            </a:r>
+            <a:r>
+              <a:rPr lang="en-IN" sz="1200" dirty="0"/>
+              <a:t>).</a:t>
+            </a:r>
+          </a:p>
+          <a:p>
+            <a:pPr lvl="1"/>
+            <a:r>
+              <a:rPr lang="en-IN" sz="1200" b="1" dirty="0"/>
+              <a:t>UML &amp; System </a:t>
+            </a:r>
+            <a:r>
+              <a:rPr lang="en-IN" sz="1200" b="1" dirty="0" err="1"/>
+              <a:t>Modeling</a:t>
+            </a:r>
+            <a:r>
+              <a:rPr lang="en-IN" sz="1200" b="1" dirty="0"/>
+              <a:t>:</a:t>
+            </a:r>
+            <a:r>
+              <a:rPr lang="en-IN" sz="1200" dirty="0"/>
+              <a:t> Use Case Diagrams, Class Diagrams, and System Architecture Flowcharts.</a:t>
+            </a:r>
+          </a:p>
+          <a:p>
+            <a:pPr lvl="1"/>
+            <a:r>
+              <a:rPr lang="en-IN" sz="1400" b="1" dirty="0"/>
+              <a:t>Security:</a:t>
+            </a:r>
+            <a:r>
+              <a:rPr lang="en-IN" sz="1400" dirty="0"/>
+              <a:t> Role-based routing guards &amp; authentication tokens.</a:t>
+            </a:r>
+          </a:p>
+          <a:p>
+            <a:pPr algn="ctr">
+              <a:defRPr sz="1500" b="1">
+                <a:solidFill>
+                  <a:srgbClr val="D4AF37"/>
+                </a:solidFill>
+                <a:latin typeface="Calibri"/>
+              </a:defRPr>
+            </a:pPr>
+            <a:endParaRPr dirty="0"/>
           </a:p>
         </p:txBody>
       </p:sp>
@@ -6104,8 +6570,8 @@
         </p:nvSpPr>
         <p:spPr>
           <a:xfrm>
-            <a:off x="6217920" y="1417320"/>
-            <a:ext cx="5394960" cy="2240280"/>
+            <a:off x="6096000" y="1417320"/>
+            <a:ext cx="5516880" cy="2903010"/>
           </a:xfrm>
           <a:prstGeom prst="roundRect">
             <a:avLst/>
@@ -6140,52 +6606,102 @@
             <a:pPr algn="ctr">
               <a:defRPr sz="1500" b="1">
                 <a:solidFill>
-                  <a:srgbClr val="38BDF8"/>
-                </a:solidFill>
-                <a:latin typeface="Calibri"/>
-              </a:defRPr>
-            </a:pPr>
-            <a:r>
-              <a:t>🎨 Frontend &amp; UI/UX Specialist  |  UI Designer &amp; Component Engineer</a:t>
-            </a:r>
-          </a:p>
-          <a:p>
-            <a:pPr>
-              <a:defRPr sz="1300">
-                <a:solidFill>
-                  <a:srgbClr val="E2E8F0"/>
-                </a:solidFill>
-                <a:latin typeface="Calibri"/>
-              </a:defRPr>
-            </a:pPr>
-            <a:r>
-              <a:t>• Implemented modern Dark Luxury theme (Navy #0A1128, Gold #D4AF37).</a:t>
-            </a:r>
-          </a:p>
-          <a:p>
-            <a:pPr>
-              <a:defRPr sz="1300">
-                <a:solidFill>
-                  <a:srgbClr val="E2E8F0"/>
-                </a:solidFill>
-                <a:latin typeface="Calibri"/>
-              </a:defRPr>
-            </a:pPr>
-            <a:r>
-              <a:t>• Built responsive grid layouts, custom scrollbar wrappers, and status badges.</a:t>
-            </a:r>
-          </a:p>
-          <a:p>
-            <a:pPr>
-              <a:defRPr sz="1300">
-                <a:solidFill>
-                  <a:srgbClr val="E2E8F0"/>
-                </a:solidFill>
-                <a:latin typeface="Calibri"/>
-              </a:defRPr>
-            </a:pPr>
-            <a:r>
-              <a:t>• Engineered client-side pagination and real-time table search filters.</a:t>
+                  <a:srgbClr val="D4AF37"/>
+                </a:solidFill>
+                <a:latin typeface="Calibri"/>
+              </a:defRPr>
+            </a:pPr>
+            <a:r>
+              <a:rPr lang="en-IN" dirty="0"/>
+              <a:t>👨‍💻 T. Santosh Vardhan </a:t>
+            </a:r>
+          </a:p>
+          <a:p>
+            <a:r>
+              <a:rPr lang="en-IN" sz="1200" b="1" dirty="0"/>
+              <a:t>Faculty Command </a:t>
+            </a:r>
+            <a:r>
+              <a:rPr lang="en-IN" sz="1200" b="1" dirty="0" err="1"/>
+              <a:t>Center</a:t>
+            </a:r>
+            <a:r>
+              <a:rPr lang="en-IN" sz="1200" b="1" dirty="0"/>
+              <a:t> &amp; Attainment Lead</a:t>
+            </a:r>
+          </a:p>
+          <a:p>
+            <a:pPr lvl="0"/>
+            <a:r>
+              <a:rPr lang="en-IN" sz="1200" b="1" dirty="0"/>
+              <a:t>Primary Module:</a:t>
+            </a:r>
+            <a:r>
+              <a:rPr lang="en-IN" sz="1200" dirty="0"/>
+              <a:t> </a:t>
+            </a:r>
+            <a:r>
+              <a:rPr lang="en-IN" sz="1200" b="1" dirty="0"/>
+              <a:t>Faculty Command </a:t>
+            </a:r>
+            <a:r>
+              <a:rPr lang="en-IN" sz="1200" b="1" dirty="0" err="1"/>
+              <a:t>Center</a:t>
+            </a:r>
+            <a:r>
+              <a:rPr lang="en-IN" sz="1200" b="1" dirty="0"/>
+              <a:t> &amp; CO-PO Attainment</a:t>
+            </a:r>
+            <a:r>
+              <a:rPr lang="en-IN" sz="1200" dirty="0"/>
+              <a:t> </a:t>
+            </a:r>
+          </a:p>
+          <a:p>
+            <a:pPr lvl="1"/>
+            <a:r>
+              <a:rPr lang="en-IN" sz="1200" dirty="0"/>
+              <a:t>Built Faculty Course Workload deck (dual-view contact hours &amp; weekly load).</a:t>
+            </a:r>
+          </a:p>
+          <a:p>
+            <a:pPr lvl="1"/>
+            <a:r>
+              <a:rPr lang="en-IN" sz="1200" dirty="0"/>
+              <a:t>Implemented Continuous Internal Evaluation (CIE) and Semester End Exam (SEE) mark entry matrices.</a:t>
+            </a:r>
+          </a:p>
+          <a:p>
+            <a:pPr lvl="0"/>
+            <a:r>
+              <a:rPr lang="en-IN" sz="1200" b="1" dirty="0"/>
+              <a:t>Engineering &amp; Architecture Ownership:</a:t>
+            </a:r>
+            <a:r>
+              <a:rPr lang="en-IN" sz="1200" dirty="0"/>
+              <a:t> </a:t>
+            </a:r>
+          </a:p>
+          <a:p>
+            <a:pPr lvl="1"/>
+            <a:r>
+              <a:rPr lang="en-IN" sz="1200" b="1" dirty="0"/>
+              <a:t>Attendance &amp; Timetable Engine:</a:t>
+            </a:r>
+            <a:r>
+              <a:rPr lang="en-IN" sz="1200" dirty="0"/>
+              <a:t> Multi-department timetable matrix and daily attendance logger.</a:t>
+            </a:r>
+          </a:p>
+          <a:p>
+            <a:pPr lvl="1"/>
+            <a:r>
+              <a:rPr lang="en-IN" sz="1200" b="1" dirty="0"/>
+              <a:t>UML &amp; Database:</a:t>
+            </a:r>
+            <a:r>
+              <a:rPr lang="en-IN" sz="1200" dirty="0"/>
+              <a:t> Entity-Relationship (ER) Diagrams, Activity Diagrams, and State Machine Diagrams.</a:t>
             </a:r>
           </a:p>
         </p:txBody>
@@ -6198,8 +6714,8 @@
         </p:nvSpPr>
         <p:spPr>
           <a:xfrm>
-            <a:off x="548640" y="3794760"/>
-            <a:ext cx="5394960" cy="2240280"/>
+            <a:off x="600652" y="4503210"/>
+            <a:ext cx="10893944" cy="2153034"/>
           </a:xfrm>
           <a:prstGeom prst="roundRect">
             <a:avLst/>
@@ -6231,186 +6747,116 @@
           <a:bodyPr wrap="square" lIns="228600" tIns="164592" rIns="228600" rtlCol="0" anchor="ctr"/>
           <a:lstStyle/>
           <a:p>
-            <a:pPr algn="ctr">
-              <a:defRPr sz="1500" b="1">
-                <a:solidFill>
-                  <a:srgbClr val="4ADE80"/>
-                </a:solidFill>
-                <a:latin typeface="Calibri"/>
-              </a:defRPr>
-            </a:pPr>
-            <a:r>
-              <a:t>⚙️ Backend &amp; Persistence  |  API &amp; Schema Engineer</a:t>
-            </a:r>
-          </a:p>
-          <a:p>
-            <a:pPr>
-              <a:defRPr sz="1300">
-                <a:solidFill>
-                  <a:srgbClr val="E2E8F0"/>
-                </a:solidFill>
-                <a:latin typeface="Calibri"/>
-              </a:defRPr>
-            </a:pPr>
-            <a:r>
-              <a:t>• Structured relational database schema (Users, Courses, Marks, Mappings).</a:t>
-            </a:r>
-          </a:p>
-          <a:p>
-            <a:pPr>
-              <a:defRPr sz="1300">
-                <a:solidFill>
-                  <a:srgbClr val="E2E8F0"/>
-                </a:solidFill>
-                <a:latin typeface="Calibri"/>
-              </a:defRPr>
-            </a:pPr>
-            <a:r>
-              <a:t>• Designed RESTful endpoint integrations and error-handling interceptors.</a:t>
-            </a:r>
-          </a:p>
-          <a:p>
-            <a:pPr>
-              <a:defRPr sz="1300">
-                <a:solidFill>
-                  <a:srgbClr val="E2E8F0"/>
-                </a:solidFill>
-                <a:latin typeface="Calibri"/>
-              </a:defRPr>
-            </a:pPr>
-            <a:r>
-              <a:t>• Constructed client-side CSV and JSON export streams.</a:t>
-            </a:r>
-          </a:p>
-        </p:txBody>
-      </p:sp>
-      <p:sp>
-        <p:nvSpPr>
-          <p:cNvPr id="7" name="Rounded Rectangle 6"/>
-          <p:cNvSpPr/>
-          <p:nvPr/>
-        </p:nvSpPr>
-        <p:spPr>
-          <a:xfrm>
-            <a:off x="6217920" y="3794760"/>
-            <a:ext cx="5394960" cy="2240280"/>
-          </a:xfrm>
-          <a:prstGeom prst="roundRect">
-            <a:avLst/>
-          </a:prstGeom>
-          <a:solidFill>
-            <a:srgbClr val="101B38"/>
-          </a:solidFill>
-          <a:ln w="15240">
-            <a:solidFill>
-              <a:srgbClr val="263862"/>
-            </a:solidFill>
-          </a:ln>
-        </p:spPr>
-        <p:style>
-          <a:lnRef idx="1">
-            <a:schemeClr val="accent1"/>
-          </a:lnRef>
-          <a:fillRef idx="3">
-            <a:schemeClr val="accent1"/>
-          </a:fillRef>
-          <a:effectRef idx="2">
-            <a:schemeClr val="accent1"/>
-          </a:effectRef>
-          <a:fontRef idx="minor">
-            <a:schemeClr val="lt1"/>
-          </a:fontRef>
-        </p:style>
-        <p:txBody>
-          <a:bodyPr wrap="square" lIns="228600" tIns="164592" rIns="228600" rtlCol="0" anchor="ctr"/>
-          <a:lstStyle/>
-          <a:p>
-            <a:pPr algn="ctr">
-              <a:defRPr sz="1500" b="1">
-                <a:solidFill>
-                  <a:srgbClr val="60A5FA"/>
-                </a:solidFill>
-                <a:latin typeface="Calibri"/>
-              </a:defRPr>
-            </a:pPr>
-            <a:r>
-              <a:t>📝 QA &amp; Documentation  |  Testing &amp; Compliance Specialist</a:t>
-            </a:r>
-          </a:p>
-          <a:p>
-            <a:pPr>
-              <a:defRPr sz="1300">
-                <a:solidFill>
-                  <a:srgbClr val="E2E8F0"/>
-                </a:solidFill>
-                <a:latin typeface="Calibri"/>
-              </a:defRPr>
-            </a:pPr>
-            <a:r>
-              <a:t>• Formulated empirical test suite (Route guards, math formulas, builds).</a:t>
-            </a:r>
-          </a:p>
-          <a:p>
-            <a:pPr>
-              <a:defRPr sz="1300">
-                <a:solidFill>
-                  <a:srgbClr val="E2E8F0"/>
-                </a:solidFill>
-                <a:latin typeface="Calibri"/>
-              </a:defRPr>
-            </a:pPr>
-            <a:r>
-              <a:t>• Mapped curriculum requirements to Washington Accord 12 Graduate Attributes.</a:t>
-            </a:r>
-          </a:p>
-          <a:p>
-            <a:pPr>
-              <a:defRPr sz="1300">
-                <a:solidFill>
-                  <a:srgbClr val="E2E8F0"/>
-                </a:solidFill>
-                <a:latin typeface="Calibri"/>
-              </a:defRPr>
-            </a:pPr>
-            <a:r>
-              <a:t>• Compiled NBA SAR Criterion 3 and NAAC 2.6 accreditation documentation.</a:t>
-            </a:r>
-          </a:p>
-        </p:txBody>
-      </p:sp>
-      <p:sp>
-        <p:nvSpPr>
-          <p:cNvPr id="8" name="TextBox 7"/>
-          <p:cNvSpPr txBox="1"/>
-          <p:nvPr/>
-        </p:nvSpPr>
-        <p:spPr>
-          <a:xfrm>
-            <a:off x="548640" y="6473952"/>
-            <a:ext cx="11094415" cy="320040"/>
-          </a:xfrm>
-          <a:prstGeom prst="rect">
-            <a:avLst/>
-          </a:prstGeom>
-          <a:noFill/>
-        </p:spPr>
-        <p:txBody>
-          <a:bodyPr wrap="none" tIns="0" bIns="0">
-            <a:spAutoFit/>
-          </a:bodyPr>
-          <a:lstStyle/>
-          <a:p>
-            <a:pPr>
-              <a:defRPr sz="1050">
-                <a:solidFill>
-                  <a:srgbClr val="94A3B8"/>
-                </a:solidFill>
-                <a:latin typeface="Calibri"/>
-              </a:defRPr>
-            </a:pPr>
-            <a:r>
-              <a:t>OBLMS — Outcome-Based Learning Management System  |  Software Technology Project  |  Slide 17 of 20</a:t>
-            </a:r>
+            <a:r>
+              <a:rPr lang="en-IN" sz="1600" dirty="0"/>
+              <a:t>                                                                                         👨‍💻 </a:t>
+            </a:r>
+            <a:r>
+              <a:rPr lang="en-IN" sz="1600" dirty="0" err="1">
+                <a:solidFill>
+                  <a:srgbClr val="FFC000"/>
+                </a:solidFill>
+              </a:rPr>
+              <a:t>M.Loukika</a:t>
+            </a:r>
+            <a:endParaRPr lang="en-IN" sz="1600" dirty="0">
+              <a:solidFill>
+                <a:srgbClr val="FFC000"/>
+              </a:solidFill>
+            </a:endParaRPr>
+          </a:p>
+          <a:p>
+            <a:r>
+              <a:rPr lang="en-IN" sz="1200" b="1" dirty="0"/>
+              <a:t>Student Portal &amp; AI Integration Lead</a:t>
+            </a:r>
+          </a:p>
+          <a:p>
+            <a:pPr lvl="0"/>
+            <a:r>
+              <a:rPr lang="en-IN" sz="1200" b="1" dirty="0"/>
+              <a:t>Primary Module:</a:t>
+            </a:r>
+            <a:r>
+              <a:rPr lang="en-IN" sz="1200" dirty="0"/>
+              <a:t> </a:t>
+            </a:r>
+            <a:r>
+              <a:rPr lang="en-IN" sz="1200" b="1" dirty="0"/>
+              <a:t>Student Results &amp; Learning Hub</a:t>
+            </a:r>
+            <a:r>
+              <a:rPr lang="en-IN" sz="1200" dirty="0"/>
+              <a:t> </a:t>
+            </a:r>
+          </a:p>
+          <a:p>
+            <a:pPr lvl="1"/>
+            <a:r>
+              <a:rPr lang="en-IN" sz="1200" dirty="0"/>
+              <a:t>Engineered Student Marksheet with expandable semester-wise grade accordions.</a:t>
+            </a:r>
+          </a:p>
+          <a:p>
+            <a:pPr lvl="1"/>
+            <a:r>
+              <a:rPr lang="en-IN" sz="1200" dirty="0"/>
+              <a:t>Automated dynamic SGPA/CGPA calculation engine and instant PDF transcript generator.</a:t>
+            </a:r>
+          </a:p>
+          <a:p>
+            <a:pPr lvl="1"/>
+            <a:r>
+              <a:rPr lang="en-IN" sz="1200" dirty="0"/>
+              <a:t>Built Student Timetable view.</a:t>
+            </a:r>
+          </a:p>
+          <a:p>
+            <a:pPr lvl="0"/>
+            <a:r>
+              <a:rPr lang="en-IN" sz="1200" b="1" dirty="0"/>
+              <a:t>Engineering &amp; Architecture Ownership:</a:t>
+            </a:r>
+            <a:r>
+              <a:rPr lang="en-IN" sz="1200" dirty="0"/>
+              <a:t> </a:t>
+            </a:r>
+          </a:p>
+          <a:p>
+            <a:pPr lvl="1"/>
+            <a:r>
+              <a:rPr lang="en-IN" sz="1200" b="1" dirty="0"/>
+              <a:t>AI Assistant Module:</a:t>
+            </a:r>
+            <a:r>
+              <a:rPr lang="en-IN" sz="1200" dirty="0"/>
+              <a:t> Integrated Google Gemini AI Chatbot (SIDDHI AI Assistant) for real-time academic queries.</a:t>
+            </a:r>
+          </a:p>
+          <a:p>
+            <a:pPr lvl="1"/>
+            <a:r>
+              <a:rPr lang="en-IN" sz="1200" b="1" dirty="0"/>
+              <a:t>UML Diagrams:</a:t>
+            </a:r>
+            <a:r>
+              <a:rPr lang="en-IN" sz="1200" dirty="0"/>
+              <a:t> Sequence Diagrams &amp; Data Flow Diagrams (DFD Level 0, 1, 2).</a:t>
+            </a:r>
+          </a:p>
+          <a:p>
+            <a:pPr lvl="1"/>
+            <a:r>
+              <a:rPr lang="en-IN" sz="1200" b="1" dirty="0"/>
+              <a:t>Frontend Styling:</a:t>
+            </a:r>
+            <a:r>
+              <a:rPr lang="en-IN" sz="1200" dirty="0"/>
+              <a:t> Responsive Luxury Dark UI theme and Material Design styling.</a:t>
+            </a:r>
+            <a:endParaRPr lang="en-IN" sz="1200" dirty="0">
+              <a:effectLst/>
+            </a:endParaRPr>
           </a:p>
         </p:txBody>
       </p:sp>
@@ -6535,20 +6981,8 @@
               </a:defRPr>
             </a:pPr>
             <a:r>
+              <a:rPr dirty="0"/>
               <a:t>18. Future Scope &amp; Technology Roadmap</a:t>
-            </a:r>
-          </a:p>
-          <a:p>
-            <a:pPr>
-              <a:defRPr sz="1300">
-                <a:solidFill>
-                  <a:srgbClr val="FDE68A"/>
-                </a:solidFill>
-                <a:latin typeface="Calibri"/>
-              </a:defRPr>
-            </a:pPr>
-            <a:r>
-              <a:t>Strategic Roadmap for Mobile and AI Integration</a:t>
             </a:r>
           </a:p>
         </p:txBody>
@@ -6821,42 +7255,6 @@
             </a:pPr>
             <a:r>
               <a:t>Build automated XML/JSON submission pipelines to upload validated SAR dossiers directly to national accreditation servers.</a:t>
-            </a:r>
-          </a:p>
-        </p:txBody>
-      </p:sp>
-      <p:sp>
-        <p:nvSpPr>
-          <p:cNvPr id="8" name="TextBox 7"/>
-          <p:cNvSpPr txBox="1"/>
-          <p:nvPr/>
-        </p:nvSpPr>
-        <p:spPr>
-          <a:xfrm>
-            <a:off x="548640" y="6473952"/>
-            <a:ext cx="11094415" cy="320040"/>
-          </a:xfrm>
-          <a:prstGeom prst="rect">
-            <a:avLst/>
-          </a:prstGeom>
-          <a:noFill/>
-        </p:spPr>
-        <p:txBody>
-          <a:bodyPr wrap="none" tIns="0" bIns="0">
-            <a:spAutoFit/>
-          </a:bodyPr>
-          <a:lstStyle/>
-          <a:p>
-            <a:pPr>
-              <a:defRPr sz="1050">
-                <a:solidFill>
-                  <a:srgbClr val="94A3B8"/>
-                </a:solidFill>
-                <a:latin typeface="Calibri"/>
-              </a:defRPr>
-            </a:pPr>
-            <a:r>
-              <a:t>OBLMS — Outcome-Based Learning Management System  |  Software Technology Project  |  Slide 18 of 20</a:t>
             </a:r>
           </a:p>
         </p:txBody>
@@ -6982,20 +7380,8 @@
               </a:defRPr>
             </a:pPr>
             <a:r>
+              <a:rPr dirty="0"/>
               <a:t>19. Conclusion &amp; Academic References</a:t>
-            </a:r>
-          </a:p>
-          <a:p>
-            <a:pPr>
-              <a:defRPr sz="1300">
-                <a:solidFill>
-                  <a:srgbClr val="FDE68A"/>
-                </a:solidFill>
-                <a:latin typeface="Calibri"/>
-              </a:defRPr>
-            </a:pPr>
-            <a:r>
-              <a:t>Executive Project Summary and Key Bibliography</a:t>
             </a:r>
           </a:p>
         </p:txBody>
@@ -7008,7 +7394,7 @@
         </p:nvSpPr>
         <p:spPr>
           <a:xfrm>
-            <a:off x="548640" y="1417320"/>
+            <a:off x="3398367" y="1356360"/>
             <a:ext cx="5394960" cy="4754880"/>
           </a:xfrm>
           <a:prstGeom prst="roundRect">
@@ -7056,6 +7442,9 @@
           </a:p>
           <a:p>
             <a:pPr>
+              <a:lnSpc>
+                <a:spcPct val="150000"/>
+              </a:lnSpc>
               <a:defRPr sz="1350">
                 <a:solidFill>
                   <a:srgbClr val="E2E8F0"/>
@@ -7070,6 +7459,9 @@
           </a:p>
           <a:p>
             <a:pPr>
+              <a:lnSpc>
+                <a:spcPct val="150000"/>
+              </a:lnSpc>
               <a:defRPr sz="1350">
                 <a:solidFill>
                   <a:srgbClr val="E2E8F0"/>
@@ -7084,6 +7476,9 @@
           </a:p>
           <a:p>
             <a:pPr>
+              <a:lnSpc>
+                <a:spcPct val="150000"/>
+              </a:lnSpc>
               <a:defRPr sz="1350">
                 <a:solidFill>
                   <a:srgbClr val="E2E8F0"/>
@@ -7098,6 +7493,9 @@
           </a:p>
           <a:p>
             <a:pPr>
+              <a:lnSpc>
+                <a:spcPct val="150000"/>
+              </a:lnSpc>
               <a:defRPr sz="1350">
                 <a:solidFill>
                   <a:srgbClr val="E2E8F0"/>
@@ -7108,154 +7506,6 @@
             <a:r>
               <a:rPr dirty="0"/>
               <a:t>✔ Verified 100% production compilation readiness with zero errors on Angular 18.</a:t>
-            </a:r>
-          </a:p>
-        </p:txBody>
-      </p:sp>
-      <p:sp>
-        <p:nvSpPr>
-          <p:cNvPr id="5" name="Rounded Rectangle 4"/>
-          <p:cNvSpPr/>
-          <p:nvPr/>
-        </p:nvSpPr>
-        <p:spPr>
-          <a:xfrm>
-            <a:off x="6217920" y="1417320"/>
-            <a:ext cx="5394960" cy="4754880"/>
-          </a:xfrm>
-          <a:prstGeom prst="roundRect">
-            <a:avLst/>
-          </a:prstGeom>
-          <a:solidFill>
-            <a:srgbClr val="101B38"/>
-          </a:solidFill>
-          <a:ln w="15240">
-            <a:solidFill>
-              <a:srgbClr val="263862"/>
-            </a:solidFill>
-          </a:ln>
-        </p:spPr>
-        <p:style>
-          <a:lnRef idx="1">
-            <a:schemeClr val="accent1"/>
-          </a:lnRef>
-          <a:fillRef idx="3">
-            <a:schemeClr val="accent1"/>
-          </a:fillRef>
-          <a:effectRef idx="2">
-            <a:schemeClr val="accent1"/>
-          </a:effectRef>
-          <a:fontRef idx="minor">
-            <a:schemeClr val="lt1"/>
-          </a:fontRef>
-        </p:style>
-        <p:txBody>
-          <a:bodyPr wrap="square" lIns="228600" tIns="228600" rIns="228600" rtlCol="0" anchor="ctr"/>
-          <a:lstStyle/>
-          <a:p>
-            <a:pPr algn="ctr">
-              <a:defRPr sz="1700" b="1">
-                <a:solidFill>
-                  <a:srgbClr val="38BDF8"/>
-                </a:solidFill>
-                <a:latin typeface="Calibri"/>
-              </a:defRPr>
-            </a:pPr>
-            <a:r>
-              <a:rPr dirty="0"/>
-              <a:t>📚 Academic References</a:t>
-            </a:r>
-          </a:p>
-          <a:p>
-            <a:pPr>
-              <a:defRPr sz="1300">
-                <a:solidFill>
-                  <a:srgbClr val="E2E8F0"/>
-                </a:solidFill>
-                <a:latin typeface="Calibri"/>
-              </a:defRPr>
-            </a:pPr>
-            <a:r>
-              <a:rPr dirty="0"/>
-              <a:t>[1] National Board of Accreditation (NBA), "SAR Format for Tier-I Engineering Programs," New Delhi, 2023.</a:t>
-            </a:r>
-          </a:p>
-          <a:p>
-            <a:pPr>
-              <a:defRPr sz="1300">
-                <a:solidFill>
-                  <a:srgbClr val="E2E8F0"/>
-                </a:solidFill>
-                <a:latin typeface="Calibri"/>
-              </a:defRPr>
-            </a:pPr>
-            <a:r>
-              <a:rPr dirty="0"/>
-              <a:t>[2] National Assessment and Accreditation Council (NAAC), "Institutional Accreditation Manual," 2024.</a:t>
-            </a:r>
-          </a:p>
-          <a:p>
-            <a:pPr>
-              <a:defRPr sz="1300">
-                <a:solidFill>
-                  <a:srgbClr val="E2E8F0"/>
-                </a:solidFill>
-                <a:latin typeface="Calibri"/>
-              </a:defRPr>
-            </a:pPr>
-            <a:r>
-              <a:rPr dirty="0"/>
-              <a:t>[3] Spady, William G., "Outcome-Based Education: Critical Issues and Answers," AASA, Arlington, VA.</a:t>
-            </a:r>
-          </a:p>
-          <a:p>
-            <a:pPr>
-              <a:defRPr sz="1300">
-                <a:solidFill>
-                  <a:srgbClr val="E2E8F0"/>
-                </a:solidFill>
-                <a:latin typeface="Calibri"/>
-              </a:defRPr>
-            </a:pPr>
-            <a:r>
-              <a:rPr dirty="0"/>
-              <a:t>[4] Angular Framework Team, "Angular v18 Standalone Architecture Documentation," Google, 2026.</a:t>
-            </a:r>
-          </a:p>
-        </p:txBody>
-      </p:sp>
-      <p:sp>
-        <p:nvSpPr>
-          <p:cNvPr id="6" name="TextBox 5"/>
-          <p:cNvSpPr txBox="1"/>
-          <p:nvPr/>
-        </p:nvSpPr>
-        <p:spPr>
-          <a:xfrm>
-            <a:off x="548640" y="6473952"/>
-            <a:ext cx="11094415" cy="320040"/>
-          </a:xfrm>
-          <a:prstGeom prst="rect">
-            <a:avLst/>
-          </a:prstGeom>
-          <a:noFill/>
-        </p:spPr>
-        <p:txBody>
-          <a:bodyPr wrap="none" tIns="0" bIns="0">
-            <a:spAutoFit/>
-          </a:bodyPr>
-          <a:lstStyle/>
-          <a:p>
-            <a:pPr>
-              <a:defRPr sz="1050">
-                <a:solidFill>
-                  <a:srgbClr val="94A3B8"/>
-                </a:solidFill>
-                <a:latin typeface="Calibri"/>
-              </a:defRPr>
-            </a:pPr>
-            <a:r>
-              <a:t>OBLMS — Outcome-Based Learning Management System  |  Software Technology Project  |  Slide 19 of 20</a:t>
             </a:r>
           </a:p>
         </p:txBody>
@@ -7381,20 +7631,8 @@
               </a:defRPr>
             </a:pPr>
             <a:r>
+              <a:rPr dirty="0"/>
               <a:t>2. Introduction</a:t>
-            </a:r>
-          </a:p>
-          <a:p>
-            <a:pPr>
-              <a:defRPr sz="1300">
-                <a:solidFill>
-                  <a:srgbClr val="FDE68A"/>
-                </a:solidFill>
-                <a:latin typeface="Calibri"/>
-              </a:defRPr>
-            </a:pPr>
-            <a:r>
-              <a:t>Real-World Context, Stakeholders &amp; High-Level Solution</a:t>
             </a:r>
           </a:p>
         </p:txBody>
@@ -7682,6 +7920,184 @@
         </p:txBody>
       </p:sp>
     </p:spTree>
+  </p:cSld>
+  <p:clrMapOvr>
+    <a:masterClrMapping/>
+  </p:clrMapOvr>
+</p:sld>
+</file>
+
+<file path=ppt/slides/slide20.xml><?xml version="1.0" encoding="utf-8"?>
+<p:sld xmlns:a="http://schemas.openxmlformats.org/drawingml/2006/main" xmlns:r="http://schemas.openxmlformats.org/officeDocument/2006/relationships" xmlns:p="http://schemas.openxmlformats.org/presentationml/2006/main">
+  <p:cSld>
+    <p:spTree>
+      <p:nvGrpSpPr>
+        <p:cNvPr id="1" name="">
+          <a:extLst>
+            <a:ext uri="{FF2B5EF4-FFF2-40B4-BE49-F238E27FC236}">
+              <a16:creationId xmlns:a16="http://schemas.microsoft.com/office/drawing/2014/main" id="{FD5548B7-BAAD-F6CF-2920-8A28E0649708}"/>
+            </a:ext>
+          </a:extLst>
+        </p:cNvPr>
+        <p:cNvGrpSpPr/>
+        <p:nvPr/>
+      </p:nvGrpSpPr>
+      <p:grpSpPr>
+        <a:xfrm>
+          <a:off x="0" y="0"/>
+          <a:ext cx="0" cy="0"/>
+          <a:chOff x="0" y="0"/>
+          <a:chExt cx="0" cy="0"/>
+        </a:xfrm>
+      </p:grpSpPr>
+      <p:sp>
+        <p:nvSpPr>
+          <p:cNvPr id="2" name="Rectangle 1">
+            <a:extLst>
+              <a:ext uri="{FF2B5EF4-FFF2-40B4-BE49-F238E27FC236}">
+                <a16:creationId xmlns:a16="http://schemas.microsoft.com/office/drawing/2014/main" id="{14E1ED5C-FB71-F279-CA72-30B466A249D9}"/>
+              </a:ext>
+            </a:extLst>
+          </p:cNvPr>
+          <p:cNvSpPr/>
+          <p:nvPr/>
+        </p:nvSpPr>
+        <p:spPr>
+          <a:xfrm>
+            <a:off x="0" y="0"/>
+            <a:ext cx="12191695" cy="6858000"/>
+          </a:xfrm>
+          <a:prstGeom prst="rect">
+            <a:avLst/>
+          </a:prstGeom>
+          <a:solidFill>
+            <a:srgbClr val="0A1128"/>
+          </a:solidFill>
+          <a:ln>
+            <a:solidFill>
+              <a:srgbClr val="0A1128"/>
+            </a:solidFill>
+          </a:ln>
+        </p:spPr>
+        <p:style>
+          <a:lnRef idx="1">
+            <a:schemeClr val="accent1"/>
+          </a:lnRef>
+          <a:fillRef idx="3">
+            <a:schemeClr val="accent1"/>
+          </a:fillRef>
+          <a:effectRef idx="2">
+            <a:schemeClr val="accent1"/>
+          </a:effectRef>
+          <a:fontRef idx="minor">
+            <a:schemeClr val="lt1"/>
+          </a:fontRef>
+        </p:style>
+        <p:txBody>
+          <a:bodyPr rtlCol="0" anchor="ctr"/>
+          <a:lstStyle/>
+          <a:p>
+            <a:pPr algn="ctr"/>
+            <a:endParaRPr/>
+          </a:p>
+        </p:txBody>
+      </p:sp>
+      <p:sp>
+        <p:nvSpPr>
+          <p:cNvPr id="4" name="Rounded Rectangle 3">
+            <a:extLst>
+              <a:ext uri="{FF2B5EF4-FFF2-40B4-BE49-F238E27FC236}">
+                <a16:creationId xmlns:a16="http://schemas.microsoft.com/office/drawing/2014/main" id="{029E15FB-531E-D9E0-B0CD-F1744B09C921}"/>
+              </a:ext>
+            </a:extLst>
+          </p:cNvPr>
+          <p:cNvSpPr/>
+          <p:nvPr/>
+        </p:nvSpPr>
+        <p:spPr>
+          <a:xfrm>
+            <a:off x="2005795" y="1051560"/>
+            <a:ext cx="8698558" cy="4754880"/>
+          </a:xfrm>
+          <a:prstGeom prst="roundRect">
+            <a:avLst/>
+          </a:prstGeom>
+          <a:solidFill>
+            <a:srgbClr val="101B38"/>
+          </a:solidFill>
+          <a:ln w="15240">
+            <a:solidFill>
+              <a:srgbClr val="263862"/>
+            </a:solidFill>
+          </a:ln>
+        </p:spPr>
+        <p:style>
+          <a:lnRef idx="1">
+            <a:schemeClr val="accent1"/>
+          </a:lnRef>
+          <a:fillRef idx="3">
+            <a:schemeClr val="accent1"/>
+          </a:fillRef>
+          <a:effectRef idx="2">
+            <a:schemeClr val="accent1"/>
+          </a:effectRef>
+          <a:fontRef idx="minor">
+            <a:schemeClr val="lt1"/>
+          </a:fontRef>
+        </p:style>
+        <p:txBody>
+          <a:bodyPr wrap="square" lIns="228600" tIns="228600" rIns="228600" rtlCol="0" anchor="ctr"/>
+          <a:lstStyle/>
+          <a:p>
+            <a:pPr algn="ctr">
+              <a:defRPr sz="1700" b="1">
+                <a:solidFill>
+                  <a:srgbClr val="D4AF37"/>
+                </a:solidFill>
+                <a:latin typeface="Calibri"/>
+              </a:defRPr>
+            </a:pPr>
+            <a:r>
+              <a:rPr lang="en-IN" sz="4000" dirty="0">
+                <a:solidFill>
+                  <a:schemeClr val="bg1"/>
+                </a:solidFill>
+                <a:latin typeface="Lucida Handwriting" panose="03010101010101010101" pitchFamily="66" charset="0"/>
+              </a:rPr>
+              <a:t>Thanking You </a:t>
+            </a:r>
+            <a:br>
+              <a:rPr lang="en-IN" sz="4000" dirty="0">
+                <a:solidFill>
+                  <a:schemeClr val="bg1"/>
+                </a:solidFill>
+                <a:latin typeface="Lucida Handwriting" panose="03010101010101010101" pitchFamily="66" charset="0"/>
+              </a:rPr>
+            </a:br>
+            <a:r>
+              <a:rPr lang="en-IN" sz="4000" dirty="0">
+                <a:solidFill>
+                  <a:schemeClr val="bg1"/>
+                </a:solidFill>
+                <a:latin typeface="Lucida Handwriting" panose="03010101010101010101" pitchFamily="66" charset="0"/>
+              </a:rPr>
+              <a:t>~~~Have a good Day~~~</a:t>
+            </a:r>
+            <a:endParaRPr sz="4000" dirty="0">
+              <a:solidFill>
+                <a:schemeClr val="bg1"/>
+              </a:solidFill>
+              <a:latin typeface="Lucida Handwriting" panose="03010101010101010101" pitchFamily="66" charset="0"/>
+            </a:endParaRPr>
+          </a:p>
+        </p:txBody>
+      </p:sp>
+    </p:spTree>
+    <p:extLst>
+      <p:ext uri="{BB962C8B-B14F-4D97-AF65-F5344CB8AC3E}">
+        <p14:creationId xmlns:p14="http://schemas.microsoft.com/office/powerpoint/2010/main" val="4009856312"/>
+      </p:ext>
+    </p:extLst>
   </p:cSld>
   <p:clrMapOvr>
     <a:masterClrMapping/>
@@ -7802,20 +8218,8 @@
               </a:defRPr>
             </a:pPr>
             <a:r>
+              <a:rPr dirty="0"/>
               <a:t>3. Problem Statement</a:t>
-            </a:r>
-          </a:p>
-          <a:p>
-            <a:pPr>
-              <a:defRPr sz="1300">
-                <a:solidFill>
-                  <a:srgbClr val="FDE68A"/>
-                </a:solidFill>
-                <a:latin typeface="Calibri"/>
-              </a:defRPr>
-            </a:pPr>
-            <a:r>
-              <a:t>Critical Institutional Pain Points &amp; Need for Modern Automation</a:t>
             </a:r>
           </a:p>
         </p:txBody>
@@ -8036,42 +8440,6 @@
             </a:pPr>
             <a:r>
               <a:t>✔ Instant one-click official PDF and CSV dossier exports.</a:t>
-            </a:r>
-          </a:p>
-        </p:txBody>
-      </p:sp>
-      <p:sp>
-        <p:nvSpPr>
-          <p:cNvPr id="6" name="TextBox 5"/>
-          <p:cNvSpPr txBox="1"/>
-          <p:nvPr/>
-        </p:nvSpPr>
-        <p:spPr>
-          <a:xfrm>
-            <a:off x="548640" y="6473952"/>
-            <a:ext cx="11094415" cy="320040"/>
-          </a:xfrm>
-          <a:prstGeom prst="rect">
-            <a:avLst/>
-          </a:prstGeom>
-          <a:noFill/>
-        </p:spPr>
-        <p:txBody>
-          <a:bodyPr wrap="none" tIns="0" bIns="0">
-            <a:spAutoFit/>
-          </a:bodyPr>
-          <a:lstStyle/>
-          <a:p>
-            <a:pPr>
-              <a:defRPr sz="1050">
-                <a:solidFill>
-                  <a:srgbClr val="94A3B8"/>
-                </a:solidFill>
-                <a:latin typeface="Calibri"/>
-              </a:defRPr>
-            </a:pPr>
-            <a:r>
-              <a:t>OBLMS — Outcome-Based Learning Management System  |  Software Technology Project  |  Slide 3 of 20</a:t>
             </a:r>
           </a:p>
         </p:txBody>
@@ -8197,20 +8565,8 @@
               </a:defRPr>
             </a:pPr>
             <a:r>
+              <a:rPr dirty="0"/>
               <a:t>4. Objectives of the Project</a:t>
-            </a:r>
-          </a:p>
-          <a:p>
-            <a:pPr>
-              <a:defRPr sz="1300">
-                <a:solidFill>
-                  <a:srgbClr val="FDE68A"/>
-                </a:solidFill>
-                <a:latin typeface="Calibri"/>
-              </a:defRPr>
-            </a:pPr>
-            <a:r>
-              <a:t>Specific Functional and Technical Targets</a:t>
             </a:r>
           </a:p>
         </p:txBody>
@@ -8483,42 +8839,6 @@
             </a:pPr>
             <a:r>
               <a:t>Build an automated NBA SAR Criterion 3 and NAAC 2.6 report generator with real-time filters, search, and CSV/JSON/PDF downloads.</a:t>
-            </a:r>
-          </a:p>
-        </p:txBody>
-      </p:sp>
-      <p:sp>
-        <p:nvSpPr>
-          <p:cNvPr id="8" name="TextBox 7"/>
-          <p:cNvSpPr txBox="1"/>
-          <p:nvPr/>
-        </p:nvSpPr>
-        <p:spPr>
-          <a:xfrm>
-            <a:off x="548640" y="6473952"/>
-            <a:ext cx="11094415" cy="320040"/>
-          </a:xfrm>
-          <a:prstGeom prst="rect">
-            <a:avLst/>
-          </a:prstGeom>
-          <a:noFill/>
-        </p:spPr>
-        <p:txBody>
-          <a:bodyPr wrap="none" tIns="0" bIns="0">
-            <a:spAutoFit/>
-          </a:bodyPr>
-          <a:lstStyle/>
-          <a:p>
-            <a:pPr>
-              <a:defRPr sz="1050">
-                <a:solidFill>
-                  <a:srgbClr val="94A3B8"/>
-                </a:solidFill>
-                <a:latin typeface="Calibri"/>
-              </a:defRPr>
-            </a:pPr>
-            <a:r>
-              <a:t>OBLMS — Outcome-Based Learning Management System  |  Software Technology Project  |  Slide 4 of 20</a:t>
             </a:r>
           </a:p>
         </p:txBody>
@@ -8644,6 +8964,7 @@
               </a:defRPr>
             </a:pPr>
             <a:r>
+              <a:rPr dirty="0"/>
               <a:t>5. Existing System vs Proposed System</a:t>
             </a:r>
           </a:p>
@@ -8656,9 +8977,7 @@
                 <a:latin typeface="Calibri"/>
               </a:defRPr>
             </a:pPr>
-            <a:r>
-              <a:t>Direct Comparison of Operational Capabilities</a:t>
-            </a:r>
+            <a:endParaRPr dirty="0"/>
           </a:p>
         </p:txBody>
       </p:sp>
@@ -9102,42 +9421,6 @@
           </a:graphicData>
         </a:graphic>
       </p:graphicFrame>
-      <p:sp>
-        <p:nvSpPr>
-          <p:cNvPr id="5" name="TextBox 4"/>
-          <p:cNvSpPr txBox="1"/>
-          <p:nvPr/>
-        </p:nvSpPr>
-        <p:spPr>
-          <a:xfrm>
-            <a:off x="548640" y="6473952"/>
-            <a:ext cx="11094415" cy="320040"/>
-          </a:xfrm>
-          <a:prstGeom prst="rect">
-            <a:avLst/>
-          </a:prstGeom>
-          <a:noFill/>
-        </p:spPr>
-        <p:txBody>
-          <a:bodyPr wrap="none" tIns="0" bIns="0">
-            <a:spAutoFit/>
-          </a:bodyPr>
-          <a:lstStyle/>
-          <a:p>
-            <a:pPr>
-              <a:defRPr sz="1050">
-                <a:solidFill>
-                  <a:srgbClr val="94A3B8"/>
-                </a:solidFill>
-                <a:latin typeface="Calibri"/>
-              </a:defRPr>
-            </a:pPr>
-            <a:r>
-              <a:t>OBLMS — Outcome-Based Learning Management System  |  Software Technology Project  |  Slide 5 of 20</a:t>
-            </a:r>
-          </a:p>
-        </p:txBody>
-      </p:sp>
     </p:spTree>
   </p:cSld>
   <p:clrMapOvr>
@@ -9217,7 +9500,7 @@
         </p:nvSpPr>
         <p:spPr>
           <a:xfrm>
-            <a:off x="548640" y="365760"/>
+            <a:off x="599373" y="800100"/>
             <a:ext cx="11094415" cy="868680"/>
           </a:xfrm>
           <a:prstGeom prst="roundRect">
@@ -9259,6 +9542,7 @@
               </a:defRPr>
             </a:pPr>
             <a:r>
+              <a:rPr dirty="0"/>
               <a:t>6. Proposed System Architecture &amp; Workflow</a:t>
             </a:r>
           </a:p>
@@ -9271,9 +9555,7 @@
                 <a:latin typeface="Calibri"/>
               </a:defRPr>
             </a:pPr>
-            <a:r>
-              <a:t>End-to-End Academic Automation Pipeline</a:t>
-            </a:r>
+            <a:endParaRPr dirty="0"/>
           </a:p>
         </p:txBody>
       </p:sp>
@@ -9285,7 +9567,7 @@
         </p:nvSpPr>
         <p:spPr>
           <a:xfrm>
-            <a:off x="548640" y="1417320"/>
+            <a:off x="599373" y="2217420"/>
             <a:ext cx="2606040" cy="3657600"/>
           </a:xfrm>
           <a:prstGeom prst="roundRect">
@@ -9327,11 +9609,15 @@
               </a:defRPr>
             </a:pPr>
             <a:r>
+              <a:rPr dirty="0"/>
               <a:t>Step 1: Curriculum &amp; Policy</a:t>
             </a:r>
           </a:p>
           <a:p>
             <a:pPr>
+              <a:lnSpc>
+                <a:spcPct val="150000"/>
+              </a:lnSpc>
               <a:defRPr sz="1300">
                 <a:solidFill>
                   <a:srgbClr val="E2E8F0"/>
@@ -9340,11 +9626,19 @@
               </a:defRPr>
             </a:pPr>
             <a:r>
-              <a:t>• Admin sets academic session (2026-27).</a:t>
+              <a:rPr dirty="0"/>
+              <a:t>• </a:t>
+            </a:r>
+            <a:r>
+              <a:rPr sz="1400" dirty="0"/>
+              <a:t>Admin sets academic session (2026-27).</a:t>
             </a:r>
           </a:p>
           <a:p>
             <a:pPr>
+              <a:lnSpc>
+                <a:spcPct val="150000"/>
+              </a:lnSpc>
               <a:defRPr sz="1300">
                 <a:solidFill>
                   <a:srgbClr val="E2E8F0"/>
@@ -9353,11 +9647,15 @@
               </a:defRPr>
             </a:pPr>
             <a:r>
+              <a:rPr sz="1400" dirty="0"/>
               <a:t>• Configures CIE/SEE weights (40/60%).</a:t>
             </a:r>
           </a:p>
           <a:p>
             <a:pPr>
+              <a:lnSpc>
+                <a:spcPct val="150000"/>
+              </a:lnSpc>
               <a:defRPr sz="1300">
                 <a:solidFill>
                   <a:srgbClr val="E2E8F0"/>
@@ -9366,6 +9664,7 @@
               </a:defRPr>
             </a:pPr>
             <a:r>
+              <a:rPr sz="1400" dirty="0"/>
               <a:t>• Establishes CO target threshold (75%).</a:t>
             </a:r>
           </a:p>
@@ -9379,7 +9678,7 @@
         </p:nvSpPr>
         <p:spPr>
           <a:xfrm>
-            <a:off x="3383280" y="1417320"/>
+            <a:off x="3489807" y="2217420"/>
             <a:ext cx="2606040" cy="3657600"/>
           </a:xfrm>
           <a:prstGeom prst="roundRect">
@@ -9421,47 +9720,37 @@
               </a:defRPr>
             </a:pPr>
             <a:r>
+              <a:rPr dirty="0"/>
               <a:t>Step 2: Workload Allotment</a:t>
             </a:r>
           </a:p>
           <a:p>
-            <a:pPr>
-              <a:defRPr sz="1300">
-                <a:solidFill>
-                  <a:srgbClr val="E2E8F0"/>
-                </a:solidFill>
-                <a:latin typeface="Calibri"/>
-              </a:defRPr>
-            </a:pPr>
-            <a:r>
-              <a:t>• HOD assigns courses to professors.</a:t>
-            </a:r>
-          </a:p>
-          <a:p>
-            <a:pPr>
-              <a:defRPr sz="1300">
-                <a:solidFill>
-                  <a:srgbClr val="E2E8F0"/>
-                </a:solidFill>
-                <a:latin typeface="Calibri"/>
-              </a:defRPr>
-            </a:pPr>
-            <a:r>
-              <a:t>• Covers 6 branches (CSE, IT, ECE, ME, CE, EEE).</a:t>
-            </a:r>
-          </a:p>
-          <a:p>
-            <a:pPr>
-              <a:defRPr sz="1300">
-                <a:solidFill>
-                  <a:srgbClr val="E2E8F0"/>
-                </a:solidFill>
-                <a:latin typeface="Calibri"/>
-              </a:defRPr>
-            </a:pPr>
-            <a:r>
-              <a:t>• Monitors weekly contact hours &amp; credits.</a:t>
-            </a:r>
+            <a:pPr lvl="0"/>
+            <a:r>
+              <a:rPr dirty="0"/>
+              <a:t> </a:t>
+            </a:r>
+            <a:r>
+              <a:rPr lang="en-IN" sz="1400" dirty="0"/>
+              <a:t>• Admin allocates courses &amp; subjects to respective faculty.</a:t>
+            </a:r>
+          </a:p>
+          <a:p>
+            <a:pPr lvl="0"/>
+            <a:r>
+              <a:rPr lang="en-IN" sz="1400" dirty="0"/>
+              <a:t>• Covers 6 engineering branches (CSE, IT, ECE, ME, CE, EEE).</a:t>
+            </a:r>
+          </a:p>
+          <a:p>
+            <a:pPr lvl="0"/>
+            <a:r>
+              <a:rPr lang="en-IN" sz="1400" dirty="0"/>
+              <a:t>• System automatically computes faculty weekly contact hours &amp; credits.</a:t>
+            </a:r>
+            <a:endParaRPr lang="en-IN" sz="1400" dirty="0">
+              <a:effectLst/>
+            </a:endParaRPr>
           </a:p>
         </p:txBody>
       </p:sp>
@@ -9473,7 +9762,7 @@
         </p:nvSpPr>
         <p:spPr>
           <a:xfrm>
-            <a:off x="6217920" y="1417320"/>
+            <a:off x="6271183" y="2217420"/>
             <a:ext cx="2606040" cy="3657600"/>
           </a:xfrm>
           <a:prstGeom prst="roundRect">
@@ -9515,11 +9804,15 @@
               </a:defRPr>
             </a:pPr>
             <a:r>
+              <a:rPr dirty="0"/>
               <a:t>Step 3: Continuous Grading</a:t>
             </a:r>
           </a:p>
           <a:p>
             <a:pPr>
+              <a:lnSpc>
+                <a:spcPct val="150000"/>
+              </a:lnSpc>
               <a:defRPr sz="1300">
                 <a:solidFill>
                   <a:srgbClr val="E2E8F0"/>
@@ -9528,11 +9821,19 @@
               </a:defRPr>
             </a:pPr>
             <a:r>
-              <a:t>• Faculty records internal CIE &amp; final SEE marks.</a:t>
+              <a:rPr dirty="0"/>
+              <a:t>• </a:t>
+            </a:r>
+            <a:r>
+              <a:rPr sz="1400" dirty="0"/>
+              <a:t>Faculty records internal CIE &amp; final SEE marks.</a:t>
             </a:r>
           </a:p>
           <a:p>
             <a:pPr>
+              <a:lnSpc>
+                <a:spcPct val="150000"/>
+              </a:lnSpc>
               <a:defRPr sz="1300">
                 <a:solidFill>
                   <a:srgbClr val="E2E8F0"/>
@@ -9541,11 +9842,15 @@
               </a:defRPr>
             </a:pPr>
             <a:r>
+              <a:rPr sz="1400" dirty="0"/>
               <a:t>• Marks map directly to Course Outcomes.</a:t>
             </a:r>
           </a:p>
           <a:p>
             <a:pPr>
+              <a:lnSpc>
+                <a:spcPct val="150000"/>
+              </a:lnSpc>
               <a:defRPr sz="1300">
                 <a:solidFill>
                   <a:srgbClr val="E2E8F0"/>
@@ -9554,6 +9859,7 @@
               </a:defRPr>
             </a:pPr>
             <a:r>
+              <a:rPr sz="1400" dirty="0"/>
               <a:t>• Instant validation prevents out-of-range entry.</a:t>
             </a:r>
           </a:p>
@@ -9567,7 +9873,7 @@
         </p:nvSpPr>
         <p:spPr>
           <a:xfrm>
-            <a:off x="9052560" y="1417320"/>
+            <a:off x="9161617" y="2217420"/>
             <a:ext cx="2606040" cy="3657600"/>
           </a:xfrm>
           <a:prstGeom prst="roundRect">
@@ -9609,11 +9915,15 @@
               </a:defRPr>
             </a:pPr>
             <a:r>
+              <a:rPr dirty="0"/>
               <a:t>Step 4: Automated Output</a:t>
             </a:r>
           </a:p>
           <a:p>
             <a:pPr>
+              <a:lnSpc>
+                <a:spcPct val="150000"/>
+              </a:lnSpc>
               <a:defRPr sz="1300">
                 <a:solidFill>
                   <a:srgbClr val="E2E8F0"/>
@@ -9622,11 +9932,19 @@
               </a:defRPr>
             </a:pPr>
             <a:r>
-              <a:t>• Engine computes SGPA, CGPA &amp; standings.</a:t>
+              <a:rPr dirty="0"/>
+              <a:t>• </a:t>
+            </a:r>
+            <a:r>
+              <a:rPr sz="1400" dirty="0"/>
+              <a:t>Engine computes SGPA, CGPA &amp; standings.</a:t>
             </a:r>
           </a:p>
           <a:p>
             <a:pPr>
+              <a:lnSpc>
+                <a:spcPct val="150000"/>
+              </a:lnSpc>
               <a:defRPr sz="1300">
                 <a:solidFill>
                   <a:srgbClr val="E2E8F0"/>
@@ -9635,11 +9953,15 @@
               </a:defRPr>
             </a:pPr>
             <a:r>
+              <a:rPr sz="1400" dirty="0"/>
               <a:t>• Generates expandable student marksheets.</a:t>
             </a:r>
           </a:p>
           <a:p>
             <a:pPr>
+              <a:lnSpc>
+                <a:spcPct val="150000"/>
+              </a:lnSpc>
               <a:defRPr sz="1300">
                 <a:solidFill>
                   <a:srgbClr val="E2E8F0"/>
@@ -9648,111 +9970,8 @@
               </a:defRPr>
             </a:pPr>
             <a:r>
+              <a:rPr sz="1400" dirty="0"/>
               <a:t>• Exports compliant NBA SAR dossiers.</a:t>
-            </a:r>
-          </a:p>
-        </p:txBody>
-      </p:sp>
-      <p:sp>
-        <p:nvSpPr>
-          <p:cNvPr id="8" name="Rounded Rectangle 7"/>
-          <p:cNvSpPr/>
-          <p:nvPr/>
-        </p:nvSpPr>
-        <p:spPr>
-          <a:xfrm>
-            <a:off x="548640" y="5257800"/>
-            <a:ext cx="11094415" cy="960120"/>
-          </a:xfrm>
-          <a:prstGeom prst="roundRect">
-            <a:avLst/>
-          </a:prstGeom>
-          <a:solidFill>
-            <a:srgbClr val="091024"/>
-          </a:solidFill>
-          <a:ln w="15240">
-            <a:solidFill>
-              <a:srgbClr val="D4AF37"/>
-            </a:solidFill>
-          </a:ln>
-        </p:spPr>
-        <p:style>
-          <a:lnRef idx="1">
-            <a:schemeClr val="accent1"/>
-          </a:lnRef>
-          <a:fillRef idx="3">
-            <a:schemeClr val="accent1"/>
-          </a:fillRef>
-          <a:effectRef idx="2">
-            <a:schemeClr val="accent1"/>
-          </a:effectRef>
-          <a:fontRef idx="minor">
-            <a:schemeClr val="lt1"/>
-          </a:fontRef>
-        </p:style>
-        <p:txBody>
-          <a:bodyPr wrap="square" lIns="228600" tIns="109728" rtlCol="0" anchor="ctr"/>
-          <a:lstStyle/>
-          <a:p>
-            <a:pPr algn="ctr">
-              <a:defRPr sz="1350" b="1">
-                <a:solidFill>
-                  <a:srgbClr val="FDE68A"/>
-                </a:solidFill>
-                <a:latin typeface="Calibri"/>
-              </a:defRPr>
-            </a:pPr>
-            <a:r>
-              <a:t>🌟 Key Architectural Highlights:</a:t>
-            </a:r>
-          </a:p>
-          <a:p>
-            <a:pPr>
-              <a:defRPr sz="1300">
-                <a:solidFill>
-                  <a:srgbClr val="FFFFFF"/>
-                </a:solidFill>
-                <a:latin typeface="Calibri"/>
-              </a:defRPr>
-            </a:pPr>
-            <a:r>
-              <a:t>• Angular 18 Standalone Architecture  • Reactive SyncService Event Bus  • Multi-Tier Role Guards  • One-Click PDF/CSV Engine</a:t>
-            </a:r>
-          </a:p>
-        </p:txBody>
-      </p:sp>
-      <p:sp>
-        <p:nvSpPr>
-          <p:cNvPr id="9" name="TextBox 8"/>
-          <p:cNvSpPr txBox="1"/>
-          <p:nvPr/>
-        </p:nvSpPr>
-        <p:spPr>
-          <a:xfrm>
-            <a:off x="548640" y="6473952"/>
-            <a:ext cx="11094415" cy="320040"/>
-          </a:xfrm>
-          <a:prstGeom prst="rect">
-            <a:avLst/>
-          </a:prstGeom>
-          <a:noFill/>
-        </p:spPr>
-        <p:txBody>
-          <a:bodyPr wrap="none" tIns="0" bIns="0">
-            <a:spAutoFit/>
-          </a:bodyPr>
-          <a:lstStyle/>
-          <a:p>
-            <a:pPr>
-              <a:defRPr sz="1050">
-                <a:solidFill>
-                  <a:srgbClr val="94A3B8"/>
-                </a:solidFill>
-                <a:latin typeface="Calibri"/>
-              </a:defRPr>
-            </a:pPr>
-            <a:r>
-              <a:t>OBLMS — Outcome-Based Learning Management System  |  Software Technology Project  |  Slide 6 of 20</a:t>
             </a:r>
           </a:p>
         </p:txBody>
@@ -9878,20 +10097,8 @@
               </a:defRPr>
             </a:pPr>
             <a:r>
+              <a:rPr dirty="0"/>
               <a:t>7. Scope of the Project</a:t>
-            </a:r>
-          </a:p>
-          <a:p>
-            <a:pPr>
-              <a:defRPr sz="1300">
-                <a:solidFill>
-                  <a:srgbClr val="FDE68A"/>
-                </a:solidFill>
-                <a:latin typeface="Calibri"/>
-              </a:defRPr>
-            </a:pPr>
-            <a:r>
-              <a:t>Implemented Capabilities vs Future Roadmap</a:t>
             </a:r>
           </a:p>
         </p:txBody>
@@ -9946,11 +10153,15 @@
               </a:defRPr>
             </a:pPr>
             <a:r>
+              <a:rPr dirty="0"/>
               <a:t>✅ Implemented Features (In Scope)</a:t>
             </a:r>
           </a:p>
           <a:p>
             <a:pPr>
+              <a:lnSpc>
+                <a:spcPct val="150000"/>
+              </a:lnSpc>
               <a:defRPr sz="1350">
                 <a:solidFill>
                   <a:srgbClr val="E2E8F0"/>
@@ -9959,11 +10170,19 @@
               </a:defRPr>
             </a:pPr>
             <a:r>
-              <a:t>• Role-Based Governance: Admin, Faculty, and Student portals with Angular Route Guards.</a:t>
+              <a:rPr dirty="0"/>
+              <a:t>• </a:t>
+            </a:r>
+            <a:r>
+              <a:rPr sz="1400" dirty="0"/>
+              <a:t>Role-Based Governance: Admin, Faculty, and Student portals with Angular Route Guards.</a:t>
             </a:r>
           </a:p>
           <a:p>
             <a:pPr>
+              <a:lnSpc>
+                <a:spcPct val="150000"/>
+              </a:lnSpc>
               <a:defRPr sz="1350">
                 <a:solidFill>
                   <a:srgbClr val="E2E8F0"/>
@@ -9972,11 +10191,15 @@
               </a:defRPr>
             </a:pPr>
             <a:r>
+              <a:rPr sz="1400" dirty="0"/>
               <a:t>• Dual-View Faculty Workload Deck: Workload cards with contact hours, credits, and branch matrix.</a:t>
             </a:r>
           </a:p>
           <a:p>
             <a:pPr>
+              <a:lnSpc>
+                <a:spcPct val="150000"/>
+              </a:lnSpc>
               <a:defRPr sz="1350">
                 <a:solidFill>
                   <a:srgbClr val="E2E8F0"/>
@@ -9985,11 +10208,15 @@
               </a:defRPr>
             </a:pPr>
             <a:r>
+              <a:rPr sz="1400" dirty="0"/>
               <a:t>• Expandable Results Deck: Student cards with SGPA/CGPA and one-click PDF transcript export.</a:t>
             </a:r>
           </a:p>
           <a:p>
             <a:pPr>
+              <a:lnSpc>
+                <a:spcPct val="150000"/>
+              </a:lnSpc>
               <a:defRPr sz="1350">
                 <a:solidFill>
                   <a:srgbClr val="E2E8F0"/>
@@ -9998,11 +10225,15 @@
               </a:defRPr>
             </a:pPr>
             <a:r>
+              <a:rPr sz="1400" dirty="0"/>
               <a:t>• NBA/NAAC Reports Generator: Multi-parameter query filters, pagination, and CSV/JSON export.</a:t>
             </a:r>
           </a:p>
           <a:p>
             <a:pPr>
+              <a:lnSpc>
+                <a:spcPct val="150000"/>
+              </a:lnSpc>
               <a:defRPr sz="1350">
                 <a:solidFill>
                   <a:srgbClr val="E2E8F0"/>
@@ -10011,7 +10242,12 @@
               </a:defRPr>
             </a:pPr>
             <a:r>
-              <a:t>• Global Policy Controls: Interactive CIE/SEE weight ratio sliders and CO target benchmarks.</a:t>
+              <a:rPr sz="1400" dirty="0"/>
+              <a:t>• Global Policy Controls: Interactive CIE/SEE weight ratio sliders and CO target benchmarks</a:t>
+            </a:r>
+            <a:r>
+              <a:rPr dirty="0"/>
+              <a:t>.</a:t>
             </a:r>
           </a:p>
         </p:txBody>
@@ -10066,11 +10302,15 @@
               </a:defRPr>
             </a:pPr>
             <a:r>
+              <a:rPr dirty="0"/>
               <a:t>🚀 Future Roadmap (Outside Current Scope)</a:t>
             </a:r>
           </a:p>
           <a:p>
             <a:pPr>
+              <a:lnSpc>
+                <a:spcPct val="150000"/>
+              </a:lnSpc>
               <a:defRPr sz="1350">
                 <a:solidFill>
                   <a:srgbClr val="E2E8F0"/>
@@ -10079,11 +10319,19 @@
               </a:defRPr>
             </a:pPr>
             <a:r>
-              <a:t>• Mobile Applications: Native Flutter / React Native mobile apps for student push alerts.</a:t>
+              <a:rPr dirty="0"/>
+              <a:t>• </a:t>
+            </a:r>
+            <a:r>
+              <a:rPr sz="1400" dirty="0"/>
+              <a:t>Mobile Applications: Native Flutter / React Native mobile apps for student push alerts.</a:t>
             </a:r>
           </a:p>
           <a:p>
             <a:pPr>
+              <a:lnSpc>
+                <a:spcPct val="150000"/>
+              </a:lnSpc>
               <a:defRPr sz="1350">
                 <a:solidFill>
                   <a:srgbClr val="E2E8F0"/>
@@ -10092,11 +10340,15 @@
               </a:defRPr>
             </a:pPr>
             <a:r>
+              <a:rPr sz="1400" dirty="0"/>
               <a:t>• AI Question Synthesis: Generative AI exam paper generation with Bloom's Taxonomy tagging.</a:t>
             </a:r>
           </a:p>
           <a:p>
             <a:pPr>
+              <a:lnSpc>
+                <a:spcPct val="150000"/>
+              </a:lnSpc>
               <a:defRPr sz="1350">
                 <a:solidFill>
                   <a:srgbClr val="E2E8F0"/>
@@ -10105,11 +10357,15 @@
               </a:defRPr>
             </a:pPr>
             <a:r>
+              <a:rPr sz="1400" dirty="0"/>
               <a:t>• Biometric &amp; RFID Attendance: Hardware IoT sensors for physical classroom attendance logging.</a:t>
             </a:r>
           </a:p>
           <a:p>
             <a:pPr>
+              <a:lnSpc>
+                <a:spcPct val="150000"/>
+              </a:lnSpc>
               <a:defRPr sz="1350">
                 <a:solidFill>
                   <a:srgbClr val="E2E8F0"/>
@@ -10118,6 +10374,7 @@
               </a:defRPr>
             </a:pPr>
             <a:r>
+              <a:rPr sz="1400" dirty="0"/>
               <a:t>• University ERP Bridge: Integration with university fee payment and finance accounting systems.</a:t>
             </a:r>
           </a:p>
@@ -10304,6 +10561,9 @@
           <a:lstStyle/>
           <a:p>
             <a:pPr algn="ctr">
+              <a:lnSpc>
+                <a:spcPct val="150000"/>
+              </a:lnSpc>
               <a:defRPr sz="1600" b="1">
                 <a:solidFill>
                   <a:srgbClr val="38BDF8"/>
@@ -10312,11 +10572,15 @@
               </a:defRPr>
             </a:pPr>
             <a:r>
+              <a:rPr sz="1600" dirty="0"/>
               <a:t>🎨 Frontend</a:t>
             </a:r>
           </a:p>
           <a:p>
             <a:pPr>
+              <a:lnSpc>
+                <a:spcPct val="150000"/>
+              </a:lnSpc>
               <a:defRPr sz="1300">
                 <a:solidFill>
                   <a:srgbClr val="E2E8F0"/>
@@ -10325,11 +10589,15 @@
               </a:defRPr>
             </a:pPr>
             <a:r>
+              <a:rPr sz="1600" dirty="0"/>
               <a:t>Framework: Angular 18 Standalone</a:t>
             </a:r>
           </a:p>
           <a:p>
             <a:pPr>
+              <a:lnSpc>
+                <a:spcPct val="150000"/>
+              </a:lnSpc>
               <a:defRPr sz="1300">
                 <a:solidFill>
                   <a:srgbClr val="E2E8F0"/>
@@ -10338,11 +10606,15 @@
               </a:defRPr>
             </a:pPr>
             <a:r>
+              <a:rPr sz="1600" dirty="0"/>
               <a:t>Language: TypeScript 5.4 / JS</a:t>
             </a:r>
           </a:p>
           <a:p>
             <a:pPr>
+              <a:lnSpc>
+                <a:spcPct val="150000"/>
+              </a:lnSpc>
               <a:defRPr sz="1300">
                 <a:solidFill>
                   <a:srgbClr val="E2E8F0"/>
@@ -10351,32 +10623,7 @@
               </a:defRPr>
             </a:pPr>
             <a:r>
-              <a:t>Styling: CSS3, Flexbox, Grid</a:t>
-            </a:r>
-          </a:p>
-          <a:p>
-            <a:pPr>
-              <a:defRPr sz="1300">
-                <a:solidFill>
-                  <a:srgbClr val="E2E8F0"/>
-                </a:solidFill>
-                <a:latin typeface="Calibri"/>
-              </a:defRPr>
-            </a:pPr>
-            <a:r>
-              <a:t>State: RxJS Observables</a:t>
-            </a:r>
-          </a:p>
-          <a:p>
-            <a:pPr>
-              <a:defRPr sz="1300">
-                <a:solidFill>
-                  <a:srgbClr val="E2E8F0"/>
-                </a:solidFill>
-                <a:latin typeface="Calibri"/>
-              </a:defRPr>
-            </a:pPr>
-            <a:r>
+              <a:rPr sz="1600" dirty="0"/>
               <a:t>Theme: Dark Luxury Theme</a:t>
             </a:r>
           </a:p>
@@ -10424,6 +10671,9 @@
           <a:lstStyle/>
           <a:p>
             <a:pPr algn="ctr">
+              <a:lnSpc>
+                <a:spcPct val="150000"/>
+              </a:lnSpc>
               <a:defRPr sz="1600" b="1">
                 <a:solidFill>
                   <a:srgbClr val="60A5FA"/>
@@ -10432,11 +10682,15 @@
               </a:defRPr>
             </a:pPr>
             <a:r>
+              <a:rPr sz="1600" dirty="0"/>
               <a:t>⚙️ Backend &amp; APIs</a:t>
             </a:r>
           </a:p>
           <a:p>
             <a:pPr>
+              <a:lnSpc>
+                <a:spcPct val="150000"/>
+              </a:lnSpc>
               <a:defRPr sz="1300">
                 <a:solidFill>
                   <a:srgbClr val="E2E8F0"/>
@@ -10445,11 +10699,15 @@
               </a:defRPr>
             </a:pPr>
             <a:r>
+              <a:rPr sz="1600" dirty="0"/>
               <a:t>Platform: Java 17 / Spring Boot</a:t>
             </a:r>
           </a:p>
           <a:p>
             <a:pPr>
+              <a:lnSpc>
+                <a:spcPct val="150000"/>
+              </a:lnSpc>
               <a:defRPr sz="1300">
                 <a:solidFill>
                   <a:srgbClr val="E2E8F0"/>
@@ -10458,11 +10716,15 @@
               </a:defRPr>
             </a:pPr>
             <a:r>
+              <a:rPr sz="1600" dirty="0"/>
               <a:t>Architecture: RESTful JSON APIs</a:t>
             </a:r>
           </a:p>
           <a:p>
             <a:pPr>
+              <a:lnSpc>
+                <a:spcPct val="150000"/>
+              </a:lnSpc>
               <a:defRPr sz="1300">
                 <a:solidFill>
                   <a:srgbClr val="E2E8F0"/>
@@ -10471,11 +10733,20 @@
               </a:defRPr>
             </a:pPr>
             <a:r>
-              <a:t>Client: Angular HttpClient</a:t>
-            </a:r>
+              <a:rPr sz="1600" dirty="0"/>
+              <a:t>Client: Angular </a:t>
+            </a:r>
+            <a:r>
+              <a:rPr sz="1600" dirty="0" err="1"/>
+              <a:t>HttpClient</a:t>
+            </a:r>
+            <a:endParaRPr sz="1600" dirty="0"/>
           </a:p>
           <a:p>
             <a:pPr>
+              <a:lnSpc>
+                <a:spcPct val="150000"/>
+              </a:lnSpc>
               <a:defRPr sz="1300">
                 <a:solidFill>
                   <a:srgbClr val="E2E8F0"/>
@@ -10484,11 +10755,23 @@
               </a:defRPr>
             </a:pPr>
             <a:r>
-              <a:t>Sync Bus: SyncService Broadcast</a:t>
+              <a:rPr sz="1600" dirty="0"/>
+              <a:t>Sync Bus: </a:t>
+            </a:r>
+            <a:r>
+              <a:rPr sz="1600" dirty="0" err="1"/>
+              <a:t>SyncService</a:t>
+            </a:r>
+            <a:r>
+              <a:rPr sz="1600" dirty="0"/>
+              <a:t> Broadcast</a:t>
             </a:r>
           </a:p>
           <a:p>
             <a:pPr>
+              <a:lnSpc>
+                <a:spcPct val="150000"/>
+              </a:lnSpc>
               <a:defRPr sz="1300">
                 <a:solidFill>
                   <a:srgbClr val="E2E8F0"/>
@@ -10497,6 +10780,7 @@
               </a:defRPr>
             </a:pPr>
             <a:r>
+              <a:rPr sz="1600" dirty="0"/>
               <a:t>Security: Role-Based Route Guards</a:t>
             </a:r>
           </a:p>
@@ -10544,6 +10828,9 @@
           <a:lstStyle/>
           <a:p>
             <a:pPr algn="ctr">
+              <a:lnSpc>
+                <a:spcPct val="150000"/>
+              </a:lnSpc>
               <a:defRPr sz="1600" b="1">
                 <a:solidFill>
                   <a:srgbClr val="4ADE80"/>
@@ -10552,11 +10839,15 @@
               </a:defRPr>
             </a:pPr>
             <a:r>
+              <a:rPr sz="1600" dirty="0"/>
               <a:t>💾 Database &amp; Cache</a:t>
             </a:r>
           </a:p>
           <a:p>
             <a:pPr>
+              <a:lnSpc>
+                <a:spcPct val="150000"/>
+              </a:lnSpc>
               <a:defRPr sz="1300">
                 <a:solidFill>
                   <a:srgbClr val="E2E8F0"/>
@@ -10565,11 +10856,15 @@
               </a:defRPr>
             </a:pPr>
             <a:r>
-              <a:t>Database: MySQL / PostgreSQL</a:t>
+              <a:rPr sz="1600" dirty="0"/>
+              <a:t>Database: MySQL </a:t>
             </a:r>
           </a:p>
           <a:p>
             <a:pPr>
+              <a:lnSpc>
+                <a:spcPct val="150000"/>
+              </a:lnSpc>
               <a:defRPr sz="1300">
                 <a:solidFill>
                   <a:srgbClr val="E2E8F0"/>
@@ -10578,11 +10873,23 @@
               </a:defRPr>
             </a:pPr>
             <a:r>
-              <a:t>Client Cache: LocalStorage Sync</a:t>
+              <a:rPr sz="1600" dirty="0"/>
+              <a:t>Client Cache: </a:t>
+            </a:r>
+            <a:r>
+              <a:rPr sz="1600" dirty="0" err="1"/>
+              <a:t>LocalStorage</a:t>
+            </a:r>
+            <a:r>
+              <a:rPr sz="1600" dirty="0"/>
+              <a:t> Sync</a:t>
             </a:r>
           </a:p>
           <a:p>
             <a:pPr>
+              <a:lnSpc>
+                <a:spcPct val="150000"/>
+              </a:lnSpc>
               <a:defRPr sz="1300">
                 <a:solidFill>
                   <a:srgbClr val="E2E8F0"/>
@@ -10591,11 +10898,15 @@
               </a:defRPr>
             </a:pPr>
             <a:r>
-              <a:t>Data Models: TypeScript DTOs</a:t>
+              <a:rPr sz="1600" dirty="0"/>
+              <a:t>Data Models: TypeScript </a:t>
             </a:r>
           </a:p>
           <a:p>
             <a:pPr>
+              <a:lnSpc>
+                <a:spcPct val="150000"/>
+              </a:lnSpc>
               <a:defRPr sz="1300">
                 <a:solidFill>
                   <a:srgbClr val="E2E8F0"/>
@@ -10604,20 +10915,8 @@
               </a:defRPr>
             </a:pPr>
             <a:r>
+              <a:rPr sz="1600" dirty="0"/>
               <a:t>Export: CSV Streams, JSON, PDF</a:t>
-            </a:r>
-          </a:p>
-          <a:p>
-            <a:pPr>
-              <a:defRPr sz="1300">
-                <a:solidFill>
-                  <a:srgbClr val="E2E8F0"/>
-                </a:solidFill>
-                <a:latin typeface="Calibri"/>
-              </a:defRPr>
-            </a:pPr>
-            <a:r>
-              <a:t>Performance: Sub-50ms query filter</a:t>
             </a:r>
           </a:p>
         </p:txBody>
@@ -10664,6 +10963,9 @@
           <a:lstStyle/>
           <a:p>
             <a:pPr algn="ctr">
+              <a:lnSpc>
+                <a:spcPct val="150000"/>
+              </a:lnSpc>
               <a:defRPr sz="1600" b="1">
                 <a:solidFill>
                   <a:srgbClr val="D4AF37"/>
@@ -10672,11 +10974,15 @@
               </a:defRPr>
             </a:pPr>
             <a:r>
+              <a:rPr sz="1600" dirty="0"/>
               <a:t>🛠️ Tools &amp; DevOps</a:t>
             </a:r>
           </a:p>
           <a:p>
             <a:pPr>
+              <a:lnSpc>
+                <a:spcPct val="150000"/>
+              </a:lnSpc>
               <a:defRPr sz="1300">
                 <a:solidFill>
                   <a:srgbClr val="E2E8F0"/>
@@ -10685,11 +10991,15 @@
               </a:defRPr>
             </a:pPr>
             <a:r>
+              <a:rPr sz="1600" dirty="0"/>
               <a:t>IDE: Visual Studio Code</a:t>
             </a:r>
           </a:p>
           <a:p>
             <a:pPr>
+              <a:lnSpc>
+                <a:spcPct val="150000"/>
+              </a:lnSpc>
               <a:defRPr sz="1300">
                 <a:solidFill>
                   <a:srgbClr val="E2E8F0"/>
@@ -10698,11 +11008,15 @@
               </a:defRPr>
             </a:pPr>
             <a:r>
+              <a:rPr sz="1600" dirty="0"/>
               <a:t>Versioning: Git &amp; GitHub</a:t>
             </a:r>
           </a:p>
           <a:p>
             <a:pPr>
+              <a:lnSpc>
+                <a:spcPct val="150000"/>
+              </a:lnSpc>
               <a:defRPr sz="1300">
                 <a:solidFill>
                   <a:srgbClr val="E2E8F0"/>
@@ -10711,11 +11025,20 @@
               </a:defRPr>
             </a:pPr>
             <a:r>
-              <a:t>Package: Node.js 20+ &amp; npm</a:t>
-            </a:r>
+              <a:rPr sz="1600" dirty="0"/>
+              <a:t>Package: Node.js 20+ &amp; </a:t>
+            </a:r>
+            <a:r>
+              <a:rPr sz="1600" dirty="0" err="1"/>
+              <a:t>npm</a:t>
+            </a:r>
+            <a:endParaRPr sz="1600" dirty="0"/>
           </a:p>
           <a:p>
             <a:pPr>
+              <a:lnSpc>
+                <a:spcPct val="150000"/>
+              </a:lnSpc>
               <a:defRPr sz="1300">
                 <a:solidFill>
                   <a:srgbClr val="E2E8F0"/>
@@ -10724,11 +11047,15 @@
               </a:defRPr>
             </a:pPr>
             <a:r>
+              <a:rPr sz="1600" dirty="0"/>
               <a:t>Verification: Production Build (0 errors)</a:t>
             </a:r>
           </a:p>
           <a:p>
             <a:pPr>
+              <a:lnSpc>
+                <a:spcPct val="150000"/>
+              </a:lnSpc>
               <a:defRPr sz="1300">
                 <a:solidFill>
                   <a:srgbClr val="E2E8F0"/>
@@ -10737,43 +11064,8 @@
               </a:defRPr>
             </a:pPr>
             <a:r>
+              <a:rPr sz="1600" dirty="0"/>
               <a:t>Target: Modern Web Browsers</a:t>
-            </a:r>
-          </a:p>
-        </p:txBody>
-      </p:sp>
-      <p:sp>
-        <p:nvSpPr>
-          <p:cNvPr id="8" name="TextBox 7"/>
-          <p:cNvSpPr txBox="1"/>
-          <p:nvPr/>
-        </p:nvSpPr>
-        <p:spPr>
-          <a:xfrm>
-            <a:off x="548640" y="6473952"/>
-            <a:ext cx="11094415" cy="320040"/>
-          </a:xfrm>
-          <a:prstGeom prst="rect">
-            <a:avLst/>
-          </a:prstGeom>
-          <a:noFill/>
-        </p:spPr>
-        <p:txBody>
-          <a:bodyPr wrap="none" tIns="0" bIns="0">
-            <a:spAutoFit/>
-          </a:bodyPr>
-          <a:lstStyle/>
-          <a:p>
-            <a:pPr>
-              <a:defRPr sz="1050">
-                <a:solidFill>
-                  <a:srgbClr val="94A3B8"/>
-                </a:solidFill>
-                <a:latin typeface="Calibri"/>
-              </a:defRPr>
-            </a:pPr>
-            <a:r>
-              <a:t>OBLMS — Outcome-Based Learning Management System  |  Software Technology Project  |  Slide 8 of 20</a:t>
             </a:r>
           </a:p>
         </p:txBody>
@@ -10899,20 +11191,8 @@
               </a:defRPr>
             </a:pPr>
             <a:r>
+              <a:rPr dirty="0"/>
               <a:t>9. System Architecture</a:t>
-            </a:r>
-          </a:p>
-          <a:p>
-            <a:pPr>
-              <a:defRPr sz="1300">
-                <a:solidFill>
-                  <a:srgbClr val="FDE68A"/>
-                </a:solidFill>
-                <a:latin typeface="Calibri"/>
-              </a:defRPr>
-            </a:pPr>
-            <a:r>
-              <a:t>Multi-Tier Client-Server Architecture with Reactive Data Flow</a:t>
             </a:r>
           </a:p>
         </p:txBody>
@@ -10925,7 +11205,7 @@
         </p:nvSpPr>
         <p:spPr>
           <a:xfrm>
-            <a:off x="548640" y="1417320"/>
+            <a:off x="548640" y="1380744"/>
             <a:ext cx="11094415" cy="1097280"/>
           </a:xfrm>
           <a:prstGeom prst="roundRect">
@@ -10958,43 +11238,98 @@
           <a:bodyPr wrap="square" lIns="228600" tIns="128016" rtlCol="0" anchor="ctr"/>
           <a:lstStyle/>
           <a:p>
-            <a:pPr algn="ctr">
-              <a:defRPr sz="1500" b="1">
-                <a:solidFill>
-                  <a:srgbClr val="38BDF8"/>
-                </a:solidFill>
-                <a:latin typeface="Calibri"/>
-              </a:defRPr>
-            </a:pPr>
-            <a:r>
-              <a:t>1. Client Presentation Layer (Angular 18 SPA)</a:t>
-            </a:r>
-          </a:p>
-          <a:p>
-            <a:pPr>
-              <a:defRPr sz="1300" b="1">
-                <a:solidFill>
-                  <a:srgbClr val="FFFFFF"/>
-                </a:solidFill>
-                <a:latin typeface="Calibri"/>
-              </a:defRPr>
-            </a:pPr>
-            <a:r>
-              <a:t>Components: Admin Console  |  Faculty Workload Deck  |  Student Results Portal  |  Accreditation Reports</a:t>
-            </a:r>
-          </a:p>
-          <a:p>
-            <a:pPr>
-              <a:defRPr sz="1200">
-                <a:solidFill>
-                  <a:srgbClr val="94A3B8"/>
-                </a:solidFill>
-                <a:latin typeface="Calibri"/>
-              </a:defRPr>
-            </a:pPr>
-            <a:r>
-              <a:t>Technology: Responsive UI, Standalone Components, Material Design</a:t>
-            </a:r>
+            <a:r>
+              <a:rPr lang="en-IN" sz="1600" b="1" dirty="0"/>
+              <a:t>                                                                </a:t>
+            </a:r>
+            <a:r>
+              <a:rPr lang="en-IN" sz="1600" b="1" dirty="0">
+                <a:solidFill>
+                  <a:schemeClr val="accent4">
+                    <a:lumMod val="60000"/>
+                    <a:lumOff val="40000"/>
+                  </a:schemeClr>
+                </a:solidFill>
+              </a:rPr>
+              <a:t>Layer 1: Presentation Layer (Angular 18 Single Page App)</a:t>
+            </a:r>
+          </a:p>
+          <a:p>
+            <a:pPr lvl="0"/>
+            <a:r>
+              <a:rPr lang="en-IN" sz="1400" b="1" dirty="0">
+                <a:solidFill>
+                  <a:schemeClr val="tx2">
+                    <a:lumMod val="40000"/>
+                    <a:lumOff val="60000"/>
+                  </a:schemeClr>
+                </a:solidFill>
+              </a:rPr>
+              <a:t>Role-Based Portals</a:t>
+            </a:r>
+            <a:r>
+              <a:rPr lang="en-IN" sz="1400" b="1" dirty="0"/>
+              <a:t>:</a:t>
+            </a:r>
+            <a:r>
+              <a:rPr lang="en-IN" sz="1400" dirty="0"/>
+              <a:t> Admin Governance Console, Faculty Command </a:t>
+            </a:r>
+            <a:r>
+              <a:rPr lang="en-IN" sz="1400" dirty="0" err="1"/>
+              <a:t>Center</a:t>
+            </a:r>
+            <a:r>
+              <a:rPr lang="en-IN" sz="1400" dirty="0"/>
+              <a:t>, Student Marksheet &amp; Timetable Hub.</a:t>
+            </a:r>
+          </a:p>
+          <a:p>
+            <a:pPr lvl="0"/>
+            <a:r>
+              <a:rPr lang="en-IN" sz="1400" b="1" dirty="0">
+                <a:solidFill>
+                  <a:schemeClr val="tx2">
+                    <a:lumMod val="40000"/>
+                    <a:lumOff val="60000"/>
+                  </a:schemeClr>
+                </a:solidFill>
+              </a:rPr>
+              <a:t>Smart Modules</a:t>
+            </a:r>
+            <a:r>
+              <a:rPr lang="en-IN" sz="1400" b="1" dirty="0"/>
+              <a:t>:</a:t>
+            </a:r>
+            <a:r>
+              <a:rPr lang="en-IN" sz="1400" dirty="0"/>
+              <a:t> AI Assistant Chatbot (Gemini Integration), Real-Time Attendance &amp; Question Bank.</a:t>
+            </a:r>
+          </a:p>
+          <a:p>
+            <a:pPr lvl="0"/>
+            <a:r>
+              <a:rPr lang="en-IN" sz="1400" b="1" dirty="0">
+                <a:solidFill>
+                  <a:schemeClr val="tx2">
+                    <a:lumMod val="40000"/>
+                    <a:lumOff val="60000"/>
+                  </a:schemeClr>
+                </a:solidFill>
+              </a:rPr>
+              <a:t>Tech Stack</a:t>
+            </a:r>
+            <a:r>
+              <a:rPr lang="en-IN" sz="1400" b="1" dirty="0"/>
+              <a:t>:</a:t>
+            </a:r>
+            <a:r>
+              <a:rPr lang="en-IN" sz="1400" dirty="0"/>
+              <a:t> Standalone Components, Material Icons, Responsive Luxury Dark UI.</a:t>
+            </a:r>
+            <a:endParaRPr lang="en-IN" sz="1400" dirty="0">
+              <a:effectLst/>
+            </a:endParaRPr>
           </a:p>
         </p:txBody>
       </p:sp>
@@ -11048,34 +11383,119 @@
               </a:defRPr>
             </a:pPr>
             <a:r>
+              <a:rPr dirty="0"/>
               <a:t>2. Client Service &amp; Reactive State Layer</a:t>
             </a:r>
           </a:p>
           <a:p>
-            <a:pPr>
-              <a:defRPr sz="1300" b="1">
-                <a:solidFill>
-                  <a:srgbClr val="FFFFFF"/>
-                </a:solidFill>
-                <a:latin typeface="Calibri"/>
-              </a:defRPr>
-            </a:pPr>
-            <a:r>
-              <a:t>Components: SyncService Event Bus  |  RoleGuard  |  ToastService  |  CourseService</a:t>
-            </a:r>
-          </a:p>
-          <a:p>
-            <a:pPr>
-              <a:defRPr sz="1200">
-                <a:solidFill>
-                  <a:srgbClr val="94A3B8"/>
-                </a:solidFill>
-                <a:latin typeface="Calibri"/>
-              </a:defRPr>
-            </a:pPr>
-            <a:r>
-              <a:t>Technology: RxJS Subject Streams, LocalStorage Distributed Sync, Client-Side Pagination</a:t>
-            </a:r>
+            <a:pPr lvl="0"/>
+            <a:r>
+              <a:rPr lang="en-IN" sz="1400" b="1" dirty="0">
+                <a:solidFill>
+                  <a:schemeClr val="accent3">
+                    <a:lumMod val="75000"/>
+                  </a:schemeClr>
+                </a:solidFill>
+              </a:rPr>
+              <a:t>Core Services</a:t>
+            </a:r>
+            <a:r>
+              <a:rPr lang="en-IN" sz="1400" b="1" dirty="0"/>
+              <a:t>:</a:t>
+            </a:r>
+            <a:r>
+              <a:rPr lang="en-IN" sz="1400" dirty="0"/>
+              <a:t> </a:t>
+            </a:r>
+            <a:r>
+              <a:rPr lang="en-IN" sz="1400" dirty="0" err="1"/>
+              <a:t>SyncService</a:t>
+            </a:r>
+            <a:r>
+              <a:rPr lang="en-IN" sz="1400" dirty="0"/>
+              <a:t> (Cross-Tab State Broadcast), </a:t>
+            </a:r>
+            <a:r>
+              <a:rPr lang="en-IN" sz="1400" dirty="0" err="1"/>
+              <a:t>AuthService</a:t>
+            </a:r>
+            <a:r>
+              <a:rPr lang="en-IN" sz="1400" dirty="0"/>
+              <a:t> (Role Guards &amp; Route Security), </a:t>
+            </a:r>
+            <a:r>
+              <a:rPr lang="en-IN" sz="1400" dirty="0" err="1"/>
+              <a:t>ExportService</a:t>
+            </a:r>
+            <a:r>
+              <a:rPr lang="en-IN" sz="1400" dirty="0"/>
+              <a:t> (Instant PDF/CSV).</a:t>
+            </a:r>
+          </a:p>
+          <a:p>
+            <a:pPr lvl="0"/>
+            <a:r>
+              <a:rPr lang="en-IN" sz="1400" b="1" dirty="0">
+                <a:solidFill>
+                  <a:schemeClr val="accent3">
+                    <a:lumMod val="75000"/>
+                  </a:schemeClr>
+                </a:solidFill>
+              </a:rPr>
+              <a:t>OBE Client Engine</a:t>
+            </a:r>
+            <a:r>
+              <a:rPr lang="en-IN" sz="1400" b="1" dirty="0"/>
+              <a:t>:</a:t>
+            </a:r>
+            <a:r>
+              <a:rPr lang="en-IN" sz="1400" dirty="0"/>
+              <a:t> Dynamic CIE/SEE (40:60) Weightage, SGPA/CGPA live recalculation, 12-PO Matrix Radar computation.</a:t>
+            </a:r>
+          </a:p>
+          <a:p>
+            <a:pPr lvl="0"/>
+            <a:r>
+              <a:rPr lang="en-IN" sz="1400" b="1" dirty="0">
+                <a:solidFill>
+                  <a:schemeClr val="accent3">
+                    <a:lumMod val="75000"/>
+                  </a:schemeClr>
+                </a:solidFill>
+              </a:rPr>
+              <a:t>Tech Stack</a:t>
+            </a:r>
+            <a:r>
+              <a:rPr lang="en-IN" sz="1400" b="1" dirty="0"/>
+              <a:t>:</a:t>
+            </a:r>
+            <a:r>
+              <a:rPr lang="en-IN" sz="1400" dirty="0"/>
+              <a:t> </a:t>
+            </a:r>
+            <a:r>
+              <a:rPr lang="en-IN" sz="1400" dirty="0" err="1"/>
+              <a:t>RxJS</a:t>
+            </a:r>
+            <a:r>
+              <a:rPr lang="en-IN" sz="1400" dirty="0"/>
+              <a:t> Observable Streams, </a:t>
+            </a:r>
+            <a:r>
+              <a:rPr lang="en-IN" sz="1400" dirty="0" err="1"/>
+              <a:t>LocalStorage</a:t>
+            </a:r>
+            <a:r>
+              <a:rPr lang="en-IN" sz="1400" dirty="0"/>
+              <a:t> State Persistence</a:t>
+            </a:r>
+            <a:r>
+              <a:rPr lang="en-IN" dirty="0"/>
+              <a:t>.</a:t>
+            </a:r>
+            <a:endParaRPr lang="en-IN" dirty="0">
+              <a:effectLst/>
+            </a:endParaRPr>
           </a:p>
         </p:txBody>
       </p:sp>
@@ -11087,7 +11507,7 @@
         </p:nvSpPr>
         <p:spPr>
           <a:xfrm>
-            <a:off x="548640" y="3831336"/>
+            <a:off x="548640" y="3794760"/>
             <a:ext cx="11094415" cy="1097280"/>
           </a:xfrm>
           <a:prstGeom prst="roundRect">
@@ -11120,43 +11540,114 @@
           <a:bodyPr wrap="square" lIns="228600" tIns="128016" rtlCol="0" anchor="ctr"/>
           <a:lstStyle/>
           <a:p>
-            <a:pPr algn="ctr">
-              <a:defRPr sz="1500" b="1">
-                <a:solidFill>
-                  <a:srgbClr val="D4AF37"/>
-                </a:solidFill>
-                <a:latin typeface="Calibri"/>
-              </a:defRPr>
-            </a:pPr>
-            <a:r>
-              <a:t>3. API Gateway &amp; Controller Layer</a:t>
-            </a:r>
-          </a:p>
-          <a:p>
-            <a:pPr>
-              <a:defRPr sz="1300" b="1">
-                <a:solidFill>
-                  <a:srgbClr val="FFFFFF"/>
-                </a:solidFill>
-                <a:latin typeface="Calibri"/>
-              </a:defRPr>
-            </a:pPr>
-            <a:r>
-              <a:t>Components: REST API Endpoints (http://localhost:8080/api/users, /courses, /obe/marks)</a:t>
-            </a:r>
-          </a:p>
-          <a:p>
-            <a:pPr>
-              <a:defRPr sz="1200">
-                <a:solidFill>
-                  <a:srgbClr val="94A3B8"/>
-                </a:solidFill>
-                <a:latin typeface="Calibri"/>
-              </a:defRPr>
-            </a:pPr>
-            <a:r>
-              <a:t>Technology: Spring Boot Controller Mappings, Input Validation, JSON Serialization</a:t>
-            </a:r>
+            <a:r>
+              <a:rPr lang="en-IN" sz="1600" b="1" dirty="0">
+                <a:solidFill>
+                  <a:srgbClr val="FFFF00"/>
+                </a:solidFill>
+              </a:rPr>
+              <a:t>                                                               Layer 3: Backend API &amp; Business Logic Layer (Java Spring Boot)</a:t>
+            </a:r>
+          </a:p>
+          <a:p>
+            <a:pPr lvl="0"/>
+            <a:r>
+              <a:rPr lang="en-IN" sz="1400" b="1" dirty="0">
+                <a:solidFill>
+                  <a:srgbClr val="00B050"/>
+                </a:solidFill>
+              </a:rPr>
+              <a:t>REST Controllers</a:t>
+            </a:r>
+            <a:r>
+              <a:rPr lang="en-IN" sz="1400" b="1" dirty="0"/>
+              <a:t>:</a:t>
+            </a:r>
+            <a:r>
+              <a:rPr lang="en-IN" sz="1400" dirty="0"/>
+              <a:t> /</a:t>
+            </a:r>
+            <a:r>
+              <a:rPr lang="en-IN" sz="1400" dirty="0" err="1"/>
+              <a:t>api</a:t>
+            </a:r>
+            <a:r>
+              <a:rPr lang="en-IN" sz="1400" dirty="0"/>
+              <a:t>/auth, /</a:t>
+            </a:r>
+            <a:r>
+              <a:rPr lang="en-IN" sz="1400" dirty="0" err="1"/>
+              <a:t>api</a:t>
+            </a:r>
+            <a:r>
+              <a:rPr lang="en-IN" sz="1400" dirty="0"/>
+              <a:t>/courses, /</a:t>
+            </a:r>
+            <a:r>
+              <a:rPr lang="en-IN" sz="1400" dirty="0" err="1"/>
+              <a:t>api</a:t>
+            </a:r>
+            <a:r>
+              <a:rPr lang="en-IN" sz="1400" dirty="0"/>
+              <a:t>/assessments, /</a:t>
+            </a:r>
+            <a:r>
+              <a:rPr lang="en-IN" sz="1400" dirty="0" err="1"/>
+              <a:t>api</a:t>
+            </a:r>
+            <a:r>
+              <a:rPr lang="en-IN" sz="1400" dirty="0"/>
+              <a:t>/timetable, /</a:t>
+            </a:r>
+            <a:r>
+              <a:rPr lang="en-IN" sz="1400" dirty="0" err="1"/>
+              <a:t>api</a:t>
+            </a:r>
+            <a:r>
+              <a:rPr lang="en-IN" sz="1400" dirty="0"/>
+              <a:t>/attendance.</a:t>
+            </a:r>
+          </a:p>
+          <a:p>
+            <a:pPr lvl="0"/>
+            <a:r>
+              <a:rPr lang="en-IN" sz="1400" b="1" dirty="0">
+                <a:solidFill>
+                  <a:srgbClr val="00B050"/>
+                </a:solidFill>
+              </a:rPr>
+              <a:t>Security &amp; Processing</a:t>
+            </a:r>
+            <a:r>
+              <a:rPr lang="en-IN" sz="1400" b="1" dirty="0"/>
+              <a:t>:</a:t>
+            </a:r>
+            <a:r>
+              <a:rPr lang="en-IN" sz="1400" dirty="0"/>
+              <a:t> Multi-tier Role Validation, JSON Serialization, Attendance &amp; Timetable Multi-Branch Dispatcher.</a:t>
+            </a:r>
+          </a:p>
+          <a:p>
+            <a:pPr lvl="0"/>
+            <a:r>
+              <a:rPr lang="en-IN" sz="1400" b="1" dirty="0">
+                <a:solidFill>
+                  <a:srgbClr val="00B050"/>
+                </a:solidFill>
+              </a:rPr>
+              <a:t>Tech Stack</a:t>
+            </a:r>
+            <a:r>
+              <a:rPr lang="en-IN" sz="1400" b="1" dirty="0"/>
+              <a:t>:</a:t>
+            </a:r>
+            <a:r>
+              <a:rPr lang="en-IN" sz="1400" dirty="0"/>
+              <a:t> Spring Boot 3.x, Spring Web, Maven, JPA / Hibernate.</a:t>
+            </a:r>
+            <a:endParaRPr lang="en-IN" sz="1400" dirty="0">
+              <a:effectLst/>
+            </a:endParaRPr>
           </a:p>
         </p:txBody>
       </p:sp>
@@ -11168,7 +11659,7 @@
         </p:nvSpPr>
         <p:spPr>
           <a:xfrm>
-            <a:off x="548640" y="5038344"/>
+            <a:off x="548639" y="5038344"/>
             <a:ext cx="11094415" cy="1097280"/>
           </a:xfrm>
           <a:prstGeom prst="roundRect">
@@ -11201,79 +11692,109 @@
           <a:bodyPr wrap="square" lIns="228600" tIns="128016" rtlCol="0" anchor="ctr"/>
           <a:lstStyle/>
           <a:p>
-            <a:pPr algn="ctr">
-              <a:defRPr sz="1500" b="1">
-                <a:solidFill>
-                  <a:srgbClr val="4ADE80"/>
-                </a:solidFill>
-                <a:latin typeface="Calibri"/>
-              </a:defRPr>
-            </a:pPr>
-            <a:r>
-              <a:t>4. OBE Processing &amp; Persistence Layer</a:t>
-            </a:r>
-          </a:p>
-          <a:p>
-            <a:pPr>
-              <a:defRPr sz="1300" b="1">
-                <a:solidFill>
-                  <a:srgbClr val="FFFFFF"/>
-                </a:solidFill>
-                <a:latin typeface="Calibri"/>
-              </a:defRPr>
-            </a:pPr>
-            <a:r>
-              <a:t>Components: OBE Calculation Engine (SGPA/CGPA, CO Attainment, 12-PO Matrix, SAR Reports)</a:t>
-            </a:r>
-          </a:p>
-          <a:p>
-            <a:pPr>
-              <a:defRPr sz="1200">
-                <a:solidFill>
-                  <a:srgbClr val="94A3B8"/>
-                </a:solidFill>
-                <a:latin typeface="Calibri"/>
-              </a:defRPr>
-            </a:pPr>
-            <a:r>
-              <a:t>Technology: MySQL / PostgreSQL Database, Schema Tables (Users, Courses, Marks, Mappings)</a:t>
-            </a:r>
-          </a:p>
-        </p:txBody>
-      </p:sp>
-      <p:sp>
-        <p:nvSpPr>
-          <p:cNvPr id="8" name="TextBox 7"/>
-          <p:cNvSpPr txBox="1"/>
-          <p:nvPr/>
-        </p:nvSpPr>
-        <p:spPr>
-          <a:xfrm>
-            <a:off x="548640" y="6473952"/>
-            <a:ext cx="11094415" cy="320040"/>
-          </a:xfrm>
-          <a:prstGeom prst="rect">
-            <a:avLst/>
-          </a:prstGeom>
-          <a:noFill/>
-        </p:spPr>
-        <p:txBody>
-          <a:bodyPr wrap="none" tIns="0" bIns="0">
-            <a:spAutoFit/>
-          </a:bodyPr>
-          <a:lstStyle/>
-          <a:p>
-            <a:pPr>
-              <a:defRPr sz="1050">
-                <a:solidFill>
-                  <a:srgbClr val="94A3B8"/>
-                </a:solidFill>
-                <a:latin typeface="Calibri"/>
-              </a:defRPr>
-            </a:pPr>
-            <a:r>
-              <a:t>OBLMS — Outcome-Based Learning Management System  |  Software Technology Project  |  Slide 9 of 20</a:t>
-            </a:r>
+            <a:r>
+              <a:rPr lang="en-IN" sz="1600" b="1" dirty="0">
+                <a:solidFill>
+                  <a:schemeClr val="accent2">
+                    <a:lumMod val="75000"/>
+                  </a:schemeClr>
+                </a:solidFill>
+              </a:rPr>
+              <a:t>                                                                    Layer 4: Data Persistence &amp; Storage Layer (MySQL / Database)</a:t>
+            </a:r>
+          </a:p>
+          <a:p>
+            <a:pPr lvl="0"/>
+            <a:r>
+              <a:rPr lang="en-IN" sz="1400" b="1" dirty="0">
+                <a:solidFill>
+                  <a:schemeClr val="accent2">
+                    <a:lumMod val="60000"/>
+                    <a:lumOff val="40000"/>
+                  </a:schemeClr>
+                </a:solidFill>
+              </a:rPr>
+              <a:t>Relational Schemas</a:t>
+            </a:r>
+            <a:r>
+              <a:rPr lang="en-IN" sz="1400" b="1" dirty="0"/>
+              <a:t>:</a:t>
+            </a:r>
+            <a:r>
+              <a:rPr lang="en-IN" sz="1400" dirty="0"/>
+              <a:t> users, courses, </a:t>
+            </a:r>
+            <a:r>
+              <a:rPr lang="en-IN" sz="1400" dirty="0" err="1"/>
+              <a:t>faculty_allocations</a:t>
+            </a:r>
+            <a:r>
+              <a:rPr lang="en-IN" sz="1400" dirty="0"/>
+              <a:t>, assessments, </a:t>
+            </a:r>
+            <a:r>
+              <a:rPr lang="en-IN" sz="1400" dirty="0" err="1"/>
+              <a:t>co_po_mappings</a:t>
+            </a:r>
+            <a:r>
+              <a:rPr lang="en-IN" sz="1400" dirty="0"/>
+              <a:t>, </a:t>
+            </a:r>
+            <a:r>
+              <a:rPr lang="en-IN" sz="1400" dirty="0" err="1"/>
+              <a:t>timetable_slots</a:t>
+            </a:r>
+            <a:r>
+              <a:rPr lang="en-IN" sz="1400" dirty="0"/>
+              <a:t>.</a:t>
+            </a:r>
+          </a:p>
+          <a:p>
+            <a:pPr lvl="0"/>
+            <a:r>
+              <a:rPr lang="en-IN" sz="1400" b="1" dirty="0">
+                <a:solidFill>
+                  <a:schemeClr val="accent2">
+                    <a:lumMod val="60000"/>
+                    <a:lumOff val="40000"/>
+                  </a:schemeClr>
+                </a:solidFill>
+              </a:rPr>
+              <a:t>Data Integrity</a:t>
+            </a:r>
+            <a:r>
+              <a:rPr lang="en-IN" sz="1400" b="1" dirty="0"/>
+              <a:t>:</a:t>
+            </a:r>
+            <a:r>
+              <a:rPr lang="en-IN" sz="1400" dirty="0"/>
+              <a:t> Foreign key constraints, automated cascades, seed records across 6 engineering branches.</a:t>
+            </a:r>
+          </a:p>
+          <a:p>
+            <a:pPr lvl="0"/>
+            <a:r>
+              <a:rPr lang="en-IN" sz="1400" b="1" dirty="0">
+                <a:solidFill>
+                  <a:schemeClr val="accent2">
+                    <a:lumMod val="60000"/>
+                    <a:lumOff val="40000"/>
+                  </a:schemeClr>
+                </a:solidFill>
+              </a:rPr>
+              <a:t>Storage Engines</a:t>
+            </a:r>
+            <a:r>
+              <a:rPr lang="en-IN" sz="1400" b="1" dirty="0"/>
+              <a:t>:</a:t>
+            </a:r>
+            <a:r>
+              <a:rPr lang="en-IN" sz="1400" dirty="0"/>
+              <a:t> MySQL RDBMS with ACID transaction compliance.</a:t>
+            </a:r>
+            <a:endParaRPr lang="en-IN" sz="1400" dirty="0">
+              <a:effectLst/>
+            </a:endParaRPr>
           </a:p>
         </p:txBody>
       </p:sp>

</xml_diff>